<commit_message>
env rescaled with cq27 msx and cq35 dermo
</commit_message>
<xml_diff>
--- a/results/figures/exporg_env.pptx
+++ b/results/figures/exporg_env.pptx
@@ -5827,7 +5827,7 @@
               <a:avLst/>
             </a:prstGeom>
             <a:solidFill>
-              <a:srgbClr val="FEBF84">
+              <a:srgbClr val="8C2981">
                 <a:alpha val="100000"/>
               </a:srgbClr>
             </a:solidFill>
@@ -5932,7 +5932,7 @@
               <a:avLst/>
             </a:prstGeom>
             <a:solidFill>
-              <a:srgbClr val="FDE3A5">
+              <a:srgbClr val="F9795D">
                 <a:alpha val="100000"/>
               </a:srgbClr>
             </a:solidFill>
@@ -6037,7 +6037,7 @@
               <a:avLst/>
             </a:prstGeom>
             <a:solidFill>
-              <a:srgbClr val="F4685C">
+              <a:srgbClr val="160F3B">
                 <a:alpha val="100000"/>
               </a:srgbClr>
             </a:solidFill>
@@ -6142,7 +6142,7 @@
               <a:avLst/>
             </a:prstGeom>
             <a:solidFill>
-              <a:srgbClr val="FED99B">
+              <a:srgbClr val="FEB67C">
                 <a:alpha val="100000"/>
               </a:srgbClr>
             </a:solidFill>
@@ -6247,7 +6247,7 @@
               <a:avLst/>
             </a:prstGeom>
             <a:solidFill>
-              <a:srgbClr val="CF4070">
+              <a:srgbClr val="0A0822">
                 <a:alpha val="100000"/>
               </a:srgbClr>
             </a:solidFill>
@@ -6969,8 +6969,8 @@
           </p:nvSpPr>
           <p:spPr>
             <a:xfrm>
-              <a:off x="1279762" y="4256468"/>
-              <a:ext cx="271942" cy="100218"/>
+              <a:off x="1318624" y="4256468"/>
+              <a:ext cx="194218" cy="100218"/>
             </a:xfrm>
             <a:prstGeom prst="rect">
               <a:avLst/>
@@ -6995,14 +6995,14 @@
               <a:r>
                 <a:rPr sz="1100">
                   <a:solidFill>
-                    <a:srgbClr val="000000">
+                    <a:srgbClr val="FFFFFF">
                       <a:alpha val="100000"/>
                     </a:srgbClr>
                   </a:solidFill>
                   <a:latin typeface="Helvetica"/>
                   <a:cs typeface="Helvetica"/>
                 </a:rPr>
-                <a:t>0.13</a:t>
+                <a:t>0.6</a:t>
               </a:r>
             </a:p>
           </p:txBody>
@@ -7140,7 +7140,7 @@
                   <a:latin typeface="Helvetica"/>
                   <a:cs typeface="Helvetica"/>
                 </a:rPr>
-                <a:t>0.06</a:t>
+                <a:t>0.28</a:t>
               </a:r>
             </a:p>
           </p:txBody>
@@ -7271,14 +7271,14 @@
               <a:r>
                 <a:rPr sz="1100">
                   <a:solidFill>
-                    <a:srgbClr val="000000">
+                    <a:srgbClr val="FFFFFF">
                       <a:alpha val="100000"/>
                     </a:srgbClr>
                   </a:solidFill>
                   <a:latin typeface="Helvetica"/>
                   <a:cs typeface="Helvetica"/>
                 </a:rPr>
-                <a:t>0.32</a:t>
+                <a:t>0.89</a:t>
               </a:r>
             </a:p>
           </p:txBody>
@@ -7416,7 +7416,7 @@
                   <a:latin typeface="Helvetica"/>
                   <a:cs typeface="Helvetica"/>
                 </a:rPr>
-                <a:t>0.08</a:t>
+                <a:t>0.15</a:t>
               </a:r>
             </a:p>
           </p:txBody>
@@ -7547,14 +7547,14 @@
               <a:r>
                 <a:rPr sz="1100">
                   <a:solidFill>
-                    <a:srgbClr val="000000">
+                    <a:srgbClr val="FFFFFF">
                       <a:alpha val="100000"/>
                     </a:srgbClr>
                   </a:solidFill>
                   <a:latin typeface="Helvetica"/>
                   <a:cs typeface="Helvetica"/>
                 </a:rPr>
-                <a:t>0.44</a:t>
+                <a:t>0.94</a:t>
               </a:r>
             </a:p>
           </p:txBody>
@@ -9485,14 +9485,14 @@
           </p:nvSpPr>
           <p:spPr>
             <a:xfrm>
-              <a:off x="3980114" y="3021897"/>
+              <a:off x="3980114" y="2630891"/>
               <a:ext cx="391006" cy="391006"/>
             </a:xfrm>
             <a:prstGeom prst="rect">
               <a:avLst/>
             </a:prstGeom>
             <a:solidFill>
-              <a:srgbClr val="3C467B">
+              <a:srgbClr val="3A74A1">
                 <a:alpha val="100000"/>
               </a:srgbClr>
             </a:solidFill>
@@ -9520,14 +9520,14 @@
           </p:nvSpPr>
           <p:spPr>
             <a:xfrm>
-              <a:off x="3980114" y="2630891"/>
+              <a:off x="3980114" y="3803910"/>
               <a:ext cx="391006" cy="391006"/>
             </a:xfrm>
             <a:prstGeom prst="rect">
               <a:avLst/>
             </a:prstGeom>
             <a:solidFill>
-              <a:srgbClr val="3985A5">
+              <a:srgbClr val="94DDC1">
                 <a:alpha val="100000"/>
               </a:srgbClr>
             </a:solidFill>
@@ -9555,14 +9555,14 @@
           </p:nvSpPr>
           <p:spPr>
             <a:xfrm>
-              <a:off x="3980114" y="4976930"/>
+              <a:off x="3980114" y="2239884"/>
               <a:ext cx="391006" cy="391006"/>
             </a:xfrm>
             <a:prstGeom prst="rect">
               <a:avLst/>
             </a:prstGeom>
             <a:solidFill>
-              <a:srgbClr val="3B70A0">
+              <a:srgbClr val="3B528D">
                 <a:alpha val="100000"/>
               </a:srgbClr>
             </a:solidFill>
@@ -9590,14 +9590,14 @@
           </p:nvSpPr>
           <p:spPr>
             <a:xfrm>
-              <a:off x="3980114" y="3412904"/>
+              <a:off x="3980114" y="3021897"/>
               <a:ext cx="391006" cy="391006"/>
             </a:xfrm>
             <a:prstGeom prst="rect">
               <a:avLst/>
             </a:prstGeom>
             <a:solidFill>
-              <a:srgbClr val="C9EEDA">
+              <a:srgbClr val="3B5590">
                 <a:alpha val="100000"/>
               </a:srgbClr>
             </a:solidFill>
@@ -9632,7 +9632,7 @@
               <a:avLst/>
             </a:prstGeom>
             <a:solidFill>
-              <a:srgbClr val="3A619D">
+              <a:srgbClr val="3B5590">
                 <a:alpha val="100000"/>
               </a:srgbClr>
             </a:solidFill>
@@ -9660,14 +9660,14 @@
           </p:nvSpPr>
           <p:spPr>
             <a:xfrm>
-              <a:off x="3980114" y="2239884"/>
+              <a:off x="3980114" y="4585923"/>
               <a:ext cx="391006" cy="391006"/>
             </a:xfrm>
             <a:prstGeom prst="rect">
               <a:avLst/>
             </a:prstGeom>
             <a:solidFill>
-              <a:srgbClr val="3B5089">
+              <a:srgbClr val="45A8AA">
                 <a:alpha val="100000"/>
               </a:srgbClr>
             </a:solidFill>
@@ -9695,14 +9695,14 @@
           </p:nvSpPr>
           <p:spPr>
             <a:xfrm>
-              <a:off x="3980114" y="4585923"/>
+              <a:off x="3980114" y="4976930"/>
               <a:ext cx="391006" cy="391006"/>
             </a:xfrm>
             <a:prstGeom prst="rect">
               <a:avLst/>
             </a:prstGeom>
             <a:solidFill>
-              <a:srgbClr val="389AA9">
+              <a:srgbClr val="3B72A1">
                 <a:alpha val="100000"/>
               </a:srgbClr>
             </a:solidFill>
@@ -9730,14 +9730,14 @@
           </p:nvSpPr>
           <p:spPr>
             <a:xfrm>
-              <a:off x="3980114" y="3803910"/>
+              <a:off x="3980114" y="3412904"/>
               <a:ext cx="391006" cy="391006"/>
             </a:xfrm>
             <a:prstGeom prst="rect">
               <a:avLst/>
             </a:prstGeom>
             <a:solidFill>
-              <a:srgbClr val="5FCDAC">
+              <a:srgbClr val="C8EEDA">
                 <a:alpha val="100000"/>
               </a:srgbClr>
             </a:solidFill>
@@ -9765,14 +9765,14 @@
           </p:nvSpPr>
           <p:spPr>
             <a:xfrm>
-              <a:off x="4371120" y="3021897"/>
+              <a:off x="4371120" y="4194917"/>
               <a:ext cx="391006" cy="391006"/>
             </a:xfrm>
             <a:prstGeom prst="rect">
               <a:avLst/>
             </a:prstGeom>
             <a:solidFill>
-              <a:srgbClr val="8DDBBE">
+              <a:srgbClr val="392E5A">
                 <a:alpha val="100000"/>
               </a:srgbClr>
             </a:solidFill>
@@ -9800,14 +9800,14 @@
           </p:nvSpPr>
           <p:spPr>
             <a:xfrm>
-              <a:off x="4371120" y="2239884"/>
+              <a:off x="4371120" y="3021897"/>
               <a:ext cx="391006" cy="391006"/>
             </a:xfrm>
             <a:prstGeom prst="rect">
               <a:avLst/>
             </a:prstGeom>
             <a:solidFill>
-              <a:srgbClr val="261C32">
+              <a:srgbClr val="8FDBBF">
                 <a:alpha val="100000"/>
               </a:srgbClr>
             </a:solidFill>
@@ -9835,14 +9835,14 @@
           </p:nvSpPr>
           <p:spPr>
             <a:xfrm>
-              <a:off x="4371120" y="2630891"/>
+              <a:off x="4371120" y="3412904"/>
               <a:ext cx="391006" cy="391006"/>
             </a:xfrm>
             <a:prstGeom prst="rect">
               <a:avLst/>
             </a:prstGeom>
             <a:solidFill>
-              <a:srgbClr val="3C487F">
+              <a:srgbClr val="3C487E">
                 <a:alpha val="100000"/>
               </a:srgbClr>
             </a:solidFill>
@@ -9871,76 +9871,6 @@
           <p:spPr>
             <a:xfrm>
               <a:off x="4371120" y="4976930"/>
-              <a:ext cx="391006" cy="391006"/>
-            </a:xfrm>
-            <a:prstGeom prst="rect">
-              <a:avLst/>
-            </a:prstGeom>
-            <a:solidFill>
-              <a:srgbClr val="281E37">
-                <a:alpha val="100000"/>
-              </a:srgbClr>
-            </a:solidFill>
-            <a:ln w="5420" cap="flat">
-              <a:solidFill>
-                <a:srgbClr val="000000">
-                  <a:alpha val="100000"/>
-                </a:srgbClr>
-              </a:solidFill>
-              <a:prstDash val="solid"/>
-              <a:miter/>
-            </a:ln>
-          </p:spPr>
-          <p:txBody>
-            <a:bodyPr/>
-            <a:lstStyle/>
-            <a:p/>
-          </p:txBody>
-        </p:sp>
-        <p:sp>
-          <p:nvSpPr>
-            <p:cNvPr id="18" name="rc18"/>
-            <p:cNvSpPr/>
-            <p:nvPr/>
-          </p:nvSpPr>
-          <p:spPr>
-            <a:xfrm>
-              <a:off x="4371120" y="4585923"/>
-              <a:ext cx="391006" cy="391006"/>
-            </a:xfrm>
-            <a:prstGeom prst="rect">
-              <a:avLst/>
-            </a:prstGeom>
-            <a:solidFill>
-              <a:srgbClr val="2B203B">
-                <a:alpha val="100000"/>
-              </a:srgbClr>
-            </a:solidFill>
-            <a:ln w="5420" cap="flat">
-              <a:solidFill>
-                <a:srgbClr val="000000">
-                  <a:alpha val="100000"/>
-                </a:srgbClr>
-              </a:solidFill>
-              <a:prstDash val="solid"/>
-              <a:miter/>
-            </a:ln>
-          </p:spPr>
-          <p:txBody>
-            <a:bodyPr/>
-            <a:lstStyle/>
-            <a:p/>
-          </p:txBody>
-        </p:sp>
-        <p:sp>
-          <p:nvSpPr>
-            <p:cNvPr id="19" name="rc19"/>
-            <p:cNvSpPr/>
-            <p:nvPr/>
-          </p:nvSpPr>
-          <p:spPr>
-            <a:xfrm>
-              <a:off x="4371120" y="3803910"/>
               <a:ext cx="391006" cy="391006"/>
             </a:xfrm>
             <a:prstGeom prst="rect">
@@ -9969,20 +9899,20 @@
         </p:sp>
         <p:sp>
           <p:nvSpPr>
-            <p:cNvPr id="20" name="rc20"/>
-            <p:cNvSpPr/>
-            <p:nvPr/>
-          </p:nvSpPr>
-          <p:spPr>
-            <a:xfrm>
-              <a:off x="4371120" y="4194917"/>
+            <p:cNvPr id="18" name="rc18"/>
+            <p:cNvSpPr/>
+            <p:nvPr/>
+          </p:nvSpPr>
+          <p:spPr>
+            <a:xfrm>
+              <a:off x="4371120" y="3803910"/>
               <a:ext cx="391006" cy="391006"/>
             </a:xfrm>
             <a:prstGeom prst="rect">
               <a:avLst/>
             </a:prstGeom>
             <a:solidFill>
-              <a:srgbClr val="302445">
+              <a:srgbClr val="3C4C84">
                 <a:alpha val="100000"/>
               </a:srgbClr>
             </a:solidFill>
@@ -10004,20 +9934,90 @@
         </p:sp>
         <p:sp>
           <p:nvSpPr>
+            <p:cNvPr id="19" name="rc19"/>
+            <p:cNvSpPr/>
+            <p:nvPr/>
+          </p:nvSpPr>
+          <p:spPr>
+            <a:xfrm>
+              <a:off x="4371120" y="4585923"/>
+              <a:ext cx="391006" cy="391006"/>
+            </a:xfrm>
+            <a:prstGeom prst="rect">
+              <a:avLst/>
+            </a:prstGeom>
+            <a:solidFill>
+              <a:srgbClr val="3A3665">
+                <a:alpha val="100000"/>
+              </a:srgbClr>
+            </a:solidFill>
+            <a:ln w="5420" cap="flat">
+              <a:solidFill>
+                <a:srgbClr val="000000">
+                  <a:alpha val="100000"/>
+                </a:srgbClr>
+              </a:solidFill>
+              <a:prstDash val="solid"/>
+              <a:miter/>
+            </a:ln>
+          </p:spPr>
+          <p:txBody>
+            <a:bodyPr/>
+            <a:lstStyle/>
+            <a:p/>
+          </p:txBody>
+        </p:sp>
+        <p:sp>
+          <p:nvSpPr>
+            <p:cNvPr id="20" name="rc20"/>
+            <p:cNvSpPr/>
+            <p:nvPr/>
+          </p:nvSpPr>
+          <p:spPr>
+            <a:xfrm>
+              <a:off x="4371120" y="2239884"/>
+              <a:ext cx="391006" cy="391006"/>
+            </a:xfrm>
+            <a:prstGeom prst="rect">
+              <a:avLst/>
+            </a:prstGeom>
+            <a:solidFill>
+              <a:srgbClr val="382A55">
+                <a:alpha val="100000"/>
+              </a:srgbClr>
+            </a:solidFill>
+            <a:ln w="5420" cap="flat">
+              <a:solidFill>
+                <a:srgbClr val="000000">
+                  <a:alpha val="100000"/>
+                </a:srgbClr>
+              </a:solidFill>
+              <a:prstDash val="solid"/>
+              <a:miter/>
+            </a:ln>
+          </p:spPr>
+          <p:txBody>
+            <a:bodyPr/>
+            <a:lstStyle/>
+            <a:p/>
+          </p:txBody>
+        </p:sp>
+        <p:sp>
+          <p:nvSpPr>
             <p:cNvPr id="21" name="rc21"/>
             <p:cNvSpPr/>
             <p:nvPr/>
           </p:nvSpPr>
           <p:spPr>
             <a:xfrm>
-              <a:off x="4371120" y="3412904"/>
+              <a:off x="4371120" y="2630891"/>
               <a:ext cx="391006" cy="391006"/>
             </a:xfrm>
             <a:prstGeom prst="rect">
               <a:avLst/>
             </a:prstGeom>
             <a:solidFill>
-              <a:srgbClr val="3B3A6B">
+              <a:srgbClr val="3B538E">
                 <a:alpha val="100000"/>
               </a:srgbClr>
             </a:solidFill>

</xml_diff>

<commit_message>
rescale env dat no pea, env dist
</commit_message>
<xml_diff>
--- a/results/figures/exporg_env.pptx
+++ b/results/figures/exporg_env.pptx
@@ -5444,8 +5444,8 @@
           </p:nvSpPr>
           <p:spPr>
             <a:xfrm>
-              <a:off x="457200" y="2324530"/>
-              <a:ext cx="8229600" cy="3077301"/>
+              <a:off x="457200" y="2633948"/>
+              <a:ext cx="8229600" cy="2458466"/>
             </a:xfrm>
             <a:prstGeom prst="rect">
               <a:avLst/>
@@ -5479,8 +5479,8 @@
           </p:nvSpPr>
           <p:spPr>
             <a:xfrm>
-              <a:off x="1026729" y="2620894"/>
-              <a:ext cx="6613066" cy="2074687"/>
+              <a:off x="889935" y="2930311"/>
+              <a:ext cx="6749860" cy="1455852"/>
             </a:xfrm>
             <a:prstGeom prst="rect">
               <a:avLst/>
@@ -5505,8 +5505,8 @@
           </p:nvSpPr>
           <p:spPr>
             <a:xfrm>
-              <a:off x="6278282" y="3982407"/>
-              <a:ext cx="648339" cy="648339"/>
+              <a:off x="6250118" y="3658238"/>
+              <a:ext cx="661751" cy="661751"/>
             </a:xfrm>
             <a:prstGeom prst="rect">
               <a:avLst/>
@@ -5540,8 +5540,8 @@
           </p:nvSpPr>
           <p:spPr>
             <a:xfrm>
-              <a:off x="6278282" y="3334068"/>
-              <a:ext cx="648339" cy="648339"/>
+              <a:off x="6250118" y="2996486"/>
+              <a:ext cx="661751" cy="661751"/>
             </a:xfrm>
             <a:prstGeom prst="rect">
               <a:avLst/>
@@ -5575,8 +5575,43 @@
           </p:nvSpPr>
           <p:spPr>
             <a:xfrm>
-              <a:off x="6278282" y="2685728"/>
-              <a:ext cx="648339" cy="648339"/>
+              <a:off x="3603114" y="3658238"/>
+              <a:ext cx="661751" cy="661751"/>
+            </a:xfrm>
+            <a:prstGeom prst="rect">
+              <a:avLst/>
+            </a:prstGeom>
+            <a:solidFill>
+              <a:srgbClr val="EC5960">
+                <a:alpha val="100000"/>
+              </a:srgbClr>
+            </a:solidFill>
+            <a:ln w="5420" cap="flat">
+              <a:solidFill>
+                <a:srgbClr val="FFFFFF">
+                  <a:alpha val="100000"/>
+                </a:srgbClr>
+              </a:solidFill>
+              <a:prstDash val="solid"/>
+              <a:miter/>
+            </a:ln>
+          </p:spPr>
+          <p:txBody>
+            <a:bodyPr/>
+            <a:lstStyle/>
+            <a:p/>
+          </p:txBody>
+        </p:sp>
+        <p:sp>
+          <p:nvSpPr>
+            <p:cNvPr id="9" name="rc9"/>
+            <p:cNvSpPr/>
+            <p:nvPr/>
+          </p:nvSpPr>
+          <p:spPr>
+            <a:xfrm>
+              <a:off x="3603114" y="2996486"/>
+              <a:ext cx="661751" cy="661751"/>
             </a:xfrm>
             <a:prstGeom prst="rect">
               <a:avLst/>
@@ -5604,20 +5639,20 @@
         </p:sp>
         <p:sp>
           <p:nvSpPr>
-            <p:cNvPr id="9" name="rc9"/>
-            <p:cNvSpPr/>
-            <p:nvPr/>
-          </p:nvSpPr>
-          <p:spPr>
-            <a:xfrm>
-              <a:off x="3684922" y="3982407"/>
-              <a:ext cx="648339" cy="648339"/>
+            <p:cNvPr id="10" name="rc10"/>
+            <p:cNvSpPr/>
+            <p:nvPr/>
+          </p:nvSpPr>
+          <p:spPr>
+            <a:xfrm>
+              <a:off x="4264865" y="3658238"/>
+              <a:ext cx="661751" cy="661751"/>
             </a:xfrm>
             <a:prstGeom prst="rect">
               <a:avLst/>
             </a:prstGeom>
             <a:solidFill>
-              <a:srgbClr val="EC5960">
+              <a:srgbClr val="772281">
                 <a:alpha val="100000"/>
               </a:srgbClr>
             </a:solidFill>
@@ -5639,14 +5674,84 @@
         </p:sp>
         <p:sp>
           <p:nvSpPr>
-            <p:cNvPr id="10" name="rc10"/>
-            <p:cNvSpPr/>
-            <p:nvPr/>
-          </p:nvSpPr>
-          <p:spPr>
-            <a:xfrm>
-              <a:off x="3684922" y="3334068"/>
-              <a:ext cx="648339" cy="648339"/>
+            <p:cNvPr id="11" name="rc11"/>
+            <p:cNvSpPr/>
+            <p:nvPr/>
+          </p:nvSpPr>
+          <p:spPr>
+            <a:xfrm>
+              <a:off x="4264865" y="2996486"/>
+              <a:ext cx="661751" cy="661751"/>
+            </a:xfrm>
+            <a:prstGeom prst="rect">
+              <a:avLst/>
+            </a:prstGeom>
+            <a:solidFill>
+              <a:srgbClr val="FEBC81">
+                <a:alpha val="100000"/>
+              </a:srgbClr>
+            </a:solidFill>
+            <a:ln w="5420" cap="flat">
+              <a:solidFill>
+                <a:srgbClr val="FFFFFF">
+                  <a:alpha val="100000"/>
+                </a:srgbClr>
+              </a:solidFill>
+              <a:prstDash val="solid"/>
+              <a:miter/>
+            </a:ln>
+          </p:spPr>
+          <p:txBody>
+            <a:bodyPr/>
+            <a:lstStyle/>
+            <a:p/>
+          </p:txBody>
+        </p:sp>
+        <p:sp>
+          <p:nvSpPr>
+            <p:cNvPr id="12" name="rc12"/>
+            <p:cNvSpPr/>
+            <p:nvPr/>
+          </p:nvSpPr>
+          <p:spPr>
+            <a:xfrm>
+              <a:off x="956110" y="3658238"/>
+              <a:ext cx="661751" cy="661751"/>
+            </a:xfrm>
+            <a:prstGeom prst="rect">
+              <a:avLst/>
+            </a:prstGeom>
+            <a:solidFill>
+              <a:srgbClr val="721F81">
+                <a:alpha val="100000"/>
+              </a:srgbClr>
+            </a:solidFill>
+            <a:ln w="5420" cap="flat">
+              <a:solidFill>
+                <a:srgbClr val="FFFFFF">
+                  <a:alpha val="100000"/>
+                </a:srgbClr>
+              </a:solidFill>
+              <a:prstDash val="solid"/>
+              <a:miter/>
+            </a:ln>
+          </p:spPr>
+          <p:txBody>
+            <a:bodyPr/>
+            <a:lstStyle/>
+            <a:p/>
+          </p:txBody>
+        </p:sp>
+        <p:sp>
+          <p:nvSpPr>
+            <p:cNvPr id="13" name="rc13"/>
+            <p:cNvSpPr/>
+            <p:nvPr/>
+          </p:nvSpPr>
+          <p:spPr>
+            <a:xfrm>
+              <a:off x="956110" y="2996486"/>
+              <a:ext cx="661751" cy="661751"/>
             </a:xfrm>
             <a:prstGeom prst="rect">
               <a:avLst/>
@@ -5674,14 +5779,49 @@
         </p:sp>
         <p:sp>
           <p:nvSpPr>
-            <p:cNvPr id="11" name="rc11"/>
-            <p:cNvSpPr/>
-            <p:nvPr/>
-          </p:nvSpPr>
-          <p:spPr>
-            <a:xfrm>
-              <a:off x="3684922" y="2685728"/>
-              <a:ext cx="648339" cy="648339"/>
+            <p:cNvPr id="14" name="rc14"/>
+            <p:cNvSpPr/>
+            <p:nvPr/>
+          </p:nvSpPr>
+          <p:spPr>
+            <a:xfrm>
+              <a:off x="1617861" y="3658238"/>
+              <a:ext cx="661751" cy="661751"/>
+            </a:xfrm>
+            <a:prstGeom prst="rect">
+              <a:avLst/>
+            </a:prstGeom>
+            <a:solidFill>
+              <a:srgbClr val="E24D66">
+                <a:alpha val="100000"/>
+              </a:srgbClr>
+            </a:solidFill>
+            <a:ln w="5420" cap="flat">
+              <a:solidFill>
+                <a:srgbClr val="FFFFFF">
+                  <a:alpha val="100000"/>
+                </a:srgbClr>
+              </a:solidFill>
+              <a:prstDash val="solid"/>
+              <a:miter/>
+            </a:ln>
+          </p:spPr>
+          <p:txBody>
+            <a:bodyPr/>
+            <a:lstStyle/>
+            <a:p/>
+          </p:txBody>
+        </p:sp>
+        <p:sp>
+          <p:nvSpPr>
+            <p:cNvPr id="15" name="rc15"/>
+            <p:cNvSpPr/>
+            <p:nvPr/>
+          </p:nvSpPr>
+          <p:spPr>
+            <a:xfrm>
+              <a:off x="1617861" y="2996486"/>
+              <a:ext cx="661751" cy="661751"/>
             </a:xfrm>
             <a:prstGeom prst="rect">
               <a:avLst/>
@@ -5709,14 +5849,294 @@
         </p:sp>
         <p:sp>
           <p:nvSpPr>
-            <p:cNvPr id="12" name="rc12"/>
-            <p:cNvSpPr/>
-            <p:nvPr/>
-          </p:nvSpPr>
-          <p:spPr>
-            <a:xfrm>
-              <a:off x="4333262" y="3982407"/>
-              <a:ext cx="648339" cy="648339"/>
+            <p:cNvPr id="16" name="rc16"/>
+            <p:cNvSpPr/>
+            <p:nvPr/>
+          </p:nvSpPr>
+          <p:spPr>
+            <a:xfrm>
+              <a:off x="2279612" y="3658238"/>
+              <a:ext cx="661751" cy="661751"/>
+            </a:xfrm>
+            <a:prstGeom prst="rect">
+              <a:avLst/>
+            </a:prstGeom>
+            <a:solidFill>
+              <a:srgbClr val="07061D">
+                <a:alpha val="100000"/>
+              </a:srgbClr>
+            </a:solidFill>
+            <a:ln w="5420" cap="flat">
+              <a:solidFill>
+                <a:srgbClr val="FFFFFF">
+                  <a:alpha val="100000"/>
+                </a:srgbClr>
+              </a:solidFill>
+              <a:prstDash val="solid"/>
+              <a:miter/>
+            </a:ln>
+          </p:spPr>
+          <p:txBody>
+            <a:bodyPr/>
+            <a:lstStyle/>
+            <a:p/>
+          </p:txBody>
+        </p:sp>
+        <p:sp>
+          <p:nvSpPr>
+            <p:cNvPr id="17" name="rc17"/>
+            <p:cNvSpPr/>
+            <p:nvPr/>
+          </p:nvSpPr>
+          <p:spPr>
+            <a:xfrm>
+              <a:off x="2279612" y="2996486"/>
+              <a:ext cx="661751" cy="661751"/>
+            </a:xfrm>
+            <a:prstGeom prst="rect">
+              <a:avLst/>
+            </a:prstGeom>
+            <a:solidFill>
+              <a:srgbClr val="FCFDBF">
+                <a:alpha val="100000"/>
+              </a:srgbClr>
+            </a:solidFill>
+            <a:ln w="5420" cap="flat">
+              <a:solidFill>
+                <a:srgbClr val="FFFFFF">
+                  <a:alpha val="100000"/>
+                </a:srgbClr>
+              </a:solidFill>
+              <a:prstDash val="solid"/>
+              <a:miter/>
+            </a:ln>
+          </p:spPr>
+          <p:txBody>
+            <a:bodyPr/>
+            <a:lstStyle/>
+            <a:p/>
+          </p:txBody>
+        </p:sp>
+        <p:sp>
+          <p:nvSpPr>
+            <p:cNvPr id="18" name="rc18"/>
+            <p:cNvSpPr/>
+            <p:nvPr/>
+          </p:nvSpPr>
+          <p:spPr>
+            <a:xfrm>
+              <a:off x="2941363" y="3658238"/>
+              <a:ext cx="661751" cy="661751"/>
+            </a:xfrm>
+            <a:prstGeom prst="rect">
+              <a:avLst/>
+            </a:prstGeom>
+            <a:solidFill>
+              <a:srgbClr val="C63C74">
+                <a:alpha val="100000"/>
+              </a:srgbClr>
+            </a:solidFill>
+            <a:ln w="5420" cap="flat">
+              <a:solidFill>
+                <a:srgbClr val="FFFFFF">
+                  <a:alpha val="100000"/>
+                </a:srgbClr>
+              </a:solidFill>
+              <a:prstDash val="solid"/>
+              <a:miter/>
+            </a:ln>
+          </p:spPr>
+          <p:txBody>
+            <a:bodyPr/>
+            <a:lstStyle/>
+            <a:p/>
+          </p:txBody>
+        </p:sp>
+        <p:sp>
+          <p:nvSpPr>
+            <p:cNvPr id="19" name="rc19"/>
+            <p:cNvSpPr/>
+            <p:nvPr/>
+          </p:nvSpPr>
+          <p:spPr>
+            <a:xfrm>
+              <a:off x="2941363" y="2996486"/>
+              <a:ext cx="661751" cy="661751"/>
+            </a:xfrm>
+            <a:prstGeom prst="rect">
+              <a:avLst/>
+            </a:prstGeom>
+            <a:solidFill>
+              <a:srgbClr val="FDE3A5">
+                <a:alpha val="100000"/>
+              </a:srgbClr>
+            </a:solidFill>
+            <a:ln w="5420" cap="flat">
+              <a:solidFill>
+                <a:srgbClr val="FFFFFF">
+                  <a:alpha val="100000"/>
+                </a:srgbClr>
+              </a:solidFill>
+              <a:prstDash val="solid"/>
+              <a:miter/>
+            </a:ln>
+          </p:spPr>
+          <p:txBody>
+            <a:bodyPr/>
+            <a:lstStyle/>
+            <a:p/>
+          </p:txBody>
+        </p:sp>
+        <p:sp>
+          <p:nvSpPr>
+            <p:cNvPr id="20" name="rc20"/>
+            <p:cNvSpPr/>
+            <p:nvPr/>
+          </p:nvSpPr>
+          <p:spPr>
+            <a:xfrm>
+              <a:off x="4926616" y="3658238"/>
+              <a:ext cx="661751" cy="661751"/>
+            </a:xfrm>
+            <a:prstGeom prst="rect">
+              <a:avLst/>
+            </a:prstGeom>
+            <a:solidFill>
+              <a:srgbClr val="0A0822">
+                <a:alpha val="100000"/>
+              </a:srgbClr>
+            </a:solidFill>
+            <a:ln w="5420" cap="flat">
+              <a:solidFill>
+                <a:srgbClr val="FFFFFF">
+                  <a:alpha val="100000"/>
+                </a:srgbClr>
+              </a:solidFill>
+              <a:prstDash val="solid"/>
+              <a:miter/>
+            </a:ln>
+          </p:spPr>
+          <p:txBody>
+            <a:bodyPr/>
+            <a:lstStyle/>
+            <a:p/>
+          </p:txBody>
+        </p:sp>
+        <p:sp>
+          <p:nvSpPr>
+            <p:cNvPr id="21" name="rc21"/>
+            <p:cNvSpPr/>
+            <p:nvPr/>
+          </p:nvSpPr>
+          <p:spPr>
+            <a:xfrm>
+              <a:off x="4926616" y="2996486"/>
+              <a:ext cx="661751" cy="661751"/>
+            </a:xfrm>
+            <a:prstGeom prst="rect">
+              <a:avLst/>
+            </a:prstGeom>
+            <a:solidFill>
+              <a:srgbClr val="F1605D">
+                <a:alpha val="100000"/>
+              </a:srgbClr>
+            </a:solidFill>
+            <a:ln w="5420" cap="flat">
+              <a:solidFill>
+                <a:srgbClr val="FFFFFF">
+                  <a:alpha val="100000"/>
+                </a:srgbClr>
+              </a:solidFill>
+              <a:prstDash val="solid"/>
+              <a:miter/>
+            </a:ln>
+          </p:spPr>
+          <p:txBody>
+            <a:bodyPr/>
+            <a:lstStyle/>
+            <a:p/>
+          </p:txBody>
+        </p:sp>
+        <p:sp>
+          <p:nvSpPr>
+            <p:cNvPr id="22" name="rc22"/>
+            <p:cNvSpPr/>
+            <p:nvPr/>
+          </p:nvSpPr>
+          <p:spPr>
+            <a:xfrm>
+              <a:off x="5588367" y="3658238"/>
+              <a:ext cx="661751" cy="661751"/>
+            </a:xfrm>
+            <a:prstGeom prst="rect">
+              <a:avLst/>
+            </a:prstGeom>
+            <a:solidFill>
+              <a:srgbClr val="FEC287">
+                <a:alpha val="100000"/>
+              </a:srgbClr>
+            </a:solidFill>
+            <a:ln w="5420" cap="flat">
+              <a:solidFill>
+                <a:srgbClr val="FFFFFF">
+                  <a:alpha val="100000"/>
+                </a:srgbClr>
+              </a:solidFill>
+              <a:prstDash val="solid"/>
+              <a:miter/>
+            </a:ln>
+          </p:spPr>
+          <p:txBody>
+            <a:bodyPr/>
+            <a:lstStyle/>
+            <a:p/>
+          </p:txBody>
+        </p:sp>
+        <p:sp>
+          <p:nvSpPr>
+            <p:cNvPr id="23" name="rc23"/>
+            <p:cNvSpPr/>
+            <p:nvPr/>
+          </p:nvSpPr>
+          <p:spPr>
+            <a:xfrm>
+              <a:off x="5588367" y="2996486"/>
+              <a:ext cx="661751" cy="661751"/>
+            </a:xfrm>
+            <a:prstGeom prst="rect">
+              <a:avLst/>
+            </a:prstGeom>
+            <a:solidFill>
+              <a:srgbClr val="FEBA80">
+                <a:alpha val="100000"/>
+              </a:srgbClr>
+            </a:solidFill>
+            <a:ln w="5420" cap="flat">
+              <a:solidFill>
+                <a:srgbClr val="FFFFFF">
+                  <a:alpha val="100000"/>
+                </a:srgbClr>
+              </a:solidFill>
+              <a:prstDash val="solid"/>
+              <a:miter/>
+            </a:ln>
+          </p:spPr>
+          <p:txBody>
+            <a:bodyPr/>
+            <a:lstStyle/>
+            <a:p/>
+          </p:txBody>
+        </p:sp>
+        <p:sp>
+          <p:nvSpPr>
+            <p:cNvPr id="24" name="rc24"/>
+            <p:cNvSpPr/>
+            <p:nvPr/>
+          </p:nvSpPr>
+          <p:spPr>
+            <a:xfrm>
+              <a:off x="6911869" y="3658238"/>
+              <a:ext cx="661751" cy="661751"/>
             </a:xfrm>
             <a:prstGeom prst="rect">
               <a:avLst/>
@@ -5744,749 +6164,14 @@
         </p:sp>
         <p:sp>
           <p:nvSpPr>
-            <p:cNvPr id="13" name="rc13"/>
-            <p:cNvSpPr/>
-            <p:nvPr/>
-          </p:nvSpPr>
-          <p:spPr>
-            <a:xfrm>
-              <a:off x="4333262" y="3334068"/>
-              <a:ext cx="648339" cy="648339"/>
-            </a:xfrm>
-            <a:prstGeom prst="rect">
-              <a:avLst/>
-            </a:prstGeom>
-            <a:solidFill>
-              <a:srgbClr val="FEBC81">
-                <a:alpha val="100000"/>
-              </a:srgbClr>
-            </a:solidFill>
-            <a:ln w="5420" cap="flat">
-              <a:solidFill>
-                <a:srgbClr val="FFFFFF">
-                  <a:alpha val="100000"/>
-                </a:srgbClr>
-              </a:solidFill>
-              <a:prstDash val="solid"/>
-              <a:miter/>
-            </a:ln>
-          </p:spPr>
-          <p:txBody>
-            <a:bodyPr/>
-            <a:lstStyle/>
-            <a:p/>
-          </p:txBody>
-        </p:sp>
-        <p:sp>
-          <p:nvSpPr>
-            <p:cNvPr id="14" name="rc14"/>
-            <p:cNvSpPr/>
-            <p:nvPr/>
-          </p:nvSpPr>
-          <p:spPr>
-            <a:xfrm>
-              <a:off x="4333262" y="2685728"/>
-              <a:ext cx="648339" cy="648339"/>
-            </a:xfrm>
-            <a:prstGeom prst="rect">
-              <a:avLst/>
-            </a:prstGeom>
-            <a:solidFill>
-              <a:srgbClr val="BB3978">
-                <a:alpha val="100000"/>
-              </a:srgbClr>
-            </a:solidFill>
-            <a:ln w="5420" cap="flat">
-              <a:solidFill>
-                <a:srgbClr val="FFFFFF">
-                  <a:alpha val="100000"/>
-                </a:srgbClr>
-              </a:solidFill>
-              <a:prstDash val="solid"/>
-              <a:miter/>
-            </a:ln>
-          </p:spPr>
-          <p:txBody>
-            <a:bodyPr/>
-            <a:lstStyle/>
-            <a:p/>
-          </p:txBody>
-        </p:sp>
-        <p:sp>
-          <p:nvSpPr>
-            <p:cNvPr id="15" name="rc15"/>
-            <p:cNvSpPr/>
-            <p:nvPr/>
-          </p:nvSpPr>
-          <p:spPr>
-            <a:xfrm>
-              <a:off x="1091563" y="3982407"/>
-              <a:ext cx="648339" cy="648339"/>
-            </a:xfrm>
-            <a:prstGeom prst="rect">
-              <a:avLst/>
-            </a:prstGeom>
-            <a:solidFill>
-              <a:srgbClr val="8C2981">
-                <a:alpha val="100000"/>
-              </a:srgbClr>
-            </a:solidFill>
-            <a:ln w="5420" cap="flat">
-              <a:solidFill>
-                <a:srgbClr val="FFFFFF">
-                  <a:alpha val="100000"/>
-                </a:srgbClr>
-              </a:solidFill>
-              <a:prstDash val="solid"/>
-              <a:miter/>
-            </a:ln>
-          </p:spPr>
-          <p:txBody>
-            <a:bodyPr/>
-            <a:lstStyle/>
-            <a:p/>
-          </p:txBody>
-        </p:sp>
-        <p:sp>
-          <p:nvSpPr>
-            <p:cNvPr id="16" name="rc16"/>
-            <p:cNvSpPr/>
-            <p:nvPr/>
-          </p:nvSpPr>
-          <p:spPr>
-            <a:xfrm>
-              <a:off x="1091563" y="3334068"/>
-              <a:ext cx="648339" cy="648339"/>
-            </a:xfrm>
-            <a:prstGeom prst="rect">
-              <a:avLst/>
-            </a:prstGeom>
-            <a:solidFill>
-              <a:srgbClr val="FCFDBF">
-                <a:alpha val="100000"/>
-              </a:srgbClr>
-            </a:solidFill>
-            <a:ln w="5420" cap="flat">
-              <a:solidFill>
-                <a:srgbClr val="FFFFFF">
-                  <a:alpha val="100000"/>
-                </a:srgbClr>
-              </a:solidFill>
-              <a:prstDash val="solid"/>
-              <a:miter/>
-            </a:ln>
-          </p:spPr>
-          <p:txBody>
-            <a:bodyPr/>
-            <a:lstStyle/>
-            <a:p/>
-          </p:txBody>
-        </p:sp>
-        <p:sp>
-          <p:nvSpPr>
-            <p:cNvPr id="17" name="rc17"/>
-            <p:cNvSpPr/>
-            <p:nvPr/>
-          </p:nvSpPr>
-          <p:spPr>
-            <a:xfrm>
-              <a:off x="1091563" y="2685728"/>
-              <a:ext cx="648339" cy="648339"/>
-            </a:xfrm>
-            <a:prstGeom prst="rect">
-              <a:avLst/>
-            </a:prstGeom>
-            <a:solidFill>
-              <a:srgbClr val="FCFDBF">
-                <a:alpha val="100000"/>
-              </a:srgbClr>
-            </a:solidFill>
-            <a:ln w="5420" cap="flat">
-              <a:solidFill>
-                <a:srgbClr val="FFFFFF">
-                  <a:alpha val="100000"/>
-                </a:srgbClr>
-              </a:solidFill>
-              <a:prstDash val="solid"/>
-              <a:miter/>
-            </a:ln>
-          </p:spPr>
-          <p:txBody>
-            <a:bodyPr/>
-            <a:lstStyle/>
-            <a:p/>
-          </p:txBody>
-        </p:sp>
-        <p:sp>
-          <p:nvSpPr>
-            <p:cNvPr id="18" name="rc18"/>
-            <p:cNvSpPr/>
-            <p:nvPr/>
-          </p:nvSpPr>
-          <p:spPr>
-            <a:xfrm>
-              <a:off x="1739903" y="3982407"/>
-              <a:ext cx="648339" cy="648339"/>
-            </a:xfrm>
-            <a:prstGeom prst="rect">
-              <a:avLst/>
-            </a:prstGeom>
-            <a:solidFill>
-              <a:srgbClr val="F9795D">
-                <a:alpha val="100000"/>
-              </a:srgbClr>
-            </a:solidFill>
-            <a:ln w="5420" cap="flat">
-              <a:solidFill>
-                <a:srgbClr val="FFFFFF">
-                  <a:alpha val="100000"/>
-                </a:srgbClr>
-              </a:solidFill>
-              <a:prstDash val="solid"/>
-              <a:miter/>
-            </a:ln>
-          </p:spPr>
-          <p:txBody>
-            <a:bodyPr/>
-            <a:lstStyle/>
-            <a:p/>
-          </p:txBody>
-        </p:sp>
-        <p:sp>
-          <p:nvSpPr>
-            <p:cNvPr id="19" name="rc19"/>
-            <p:cNvSpPr/>
-            <p:nvPr/>
-          </p:nvSpPr>
-          <p:spPr>
-            <a:xfrm>
-              <a:off x="1739903" y="3334068"/>
-              <a:ext cx="648339" cy="648339"/>
-            </a:xfrm>
-            <a:prstGeom prst="rect">
-              <a:avLst/>
-            </a:prstGeom>
-            <a:solidFill>
-              <a:srgbClr val="FCFDBF">
-                <a:alpha val="100000"/>
-              </a:srgbClr>
-            </a:solidFill>
-            <a:ln w="5420" cap="flat">
-              <a:solidFill>
-                <a:srgbClr val="FFFFFF">
-                  <a:alpha val="100000"/>
-                </a:srgbClr>
-              </a:solidFill>
-              <a:prstDash val="solid"/>
-              <a:miter/>
-            </a:ln>
-          </p:spPr>
-          <p:txBody>
-            <a:bodyPr/>
-            <a:lstStyle/>
-            <a:p/>
-          </p:txBody>
-        </p:sp>
-        <p:sp>
-          <p:nvSpPr>
-            <p:cNvPr id="20" name="rc20"/>
-            <p:cNvSpPr/>
-            <p:nvPr/>
-          </p:nvSpPr>
-          <p:spPr>
-            <a:xfrm>
-              <a:off x="1739903" y="2685728"/>
-              <a:ext cx="648339" cy="648339"/>
-            </a:xfrm>
-            <a:prstGeom prst="rect">
-              <a:avLst/>
-            </a:prstGeom>
-            <a:solidFill>
-              <a:srgbClr val="FCFDBF">
-                <a:alpha val="100000"/>
-              </a:srgbClr>
-            </a:solidFill>
-            <a:ln w="5420" cap="flat">
-              <a:solidFill>
-                <a:srgbClr val="FFFFFF">
-                  <a:alpha val="100000"/>
-                </a:srgbClr>
-              </a:solidFill>
-              <a:prstDash val="solid"/>
-              <a:miter/>
-            </a:ln>
-          </p:spPr>
-          <p:txBody>
-            <a:bodyPr/>
-            <a:lstStyle/>
-            <a:p/>
-          </p:txBody>
-        </p:sp>
-        <p:sp>
-          <p:nvSpPr>
-            <p:cNvPr id="21" name="rc21"/>
-            <p:cNvSpPr/>
-            <p:nvPr/>
-          </p:nvSpPr>
-          <p:spPr>
-            <a:xfrm>
-              <a:off x="2388243" y="3982407"/>
-              <a:ext cx="648339" cy="648339"/>
-            </a:xfrm>
-            <a:prstGeom prst="rect">
-              <a:avLst/>
-            </a:prstGeom>
-            <a:solidFill>
-              <a:srgbClr val="160F3B">
-                <a:alpha val="100000"/>
-              </a:srgbClr>
-            </a:solidFill>
-            <a:ln w="5420" cap="flat">
-              <a:solidFill>
-                <a:srgbClr val="FFFFFF">
-                  <a:alpha val="100000"/>
-                </a:srgbClr>
-              </a:solidFill>
-              <a:prstDash val="solid"/>
-              <a:miter/>
-            </a:ln>
-          </p:spPr>
-          <p:txBody>
-            <a:bodyPr/>
-            <a:lstStyle/>
-            <a:p/>
-          </p:txBody>
-        </p:sp>
-        <p:sp>
-          <p:nvSpPr>
-            <p:cNvPr id="22" name="rc22"/>
-            <p:cNvSpPr/>
-            <p:nvPr/>
-          </p:nvSpPr>
-          <p:spPr>
-            <a:xfrm>
-              <a:off x="2388243" y="3334068"/>
-              <a:ext cx="648339" cy="648339"/>
-            </a:xfrm>
-            <a:prstGeom prst="rect">
-              <a:avLst/>
-            </a:prstGeom>
-            <a:solidFill>
-              <a:srgbClr val="FCFDBF">
-                <a:alpha val="100000"/>
-              </a:srgbClr>
-            </a:solidFill>
-            <a:ln w="5420" cap="flat">
-              <a:solidFill>
-                <a:srgbClr val="FFFFFF">
-                  <a:alpha val="100000"/>
-                </a:srgbClr>
-              </a:solidFill>
-              <a:prstDash val="solid"/>
-              <a:miter/>
-            </a:ln>
-          </p:spPr>
-          <p:txBody>
-            <a:bodyPr/>
-            <a:lstStyle/>
-            <a:p/>
-          </p:txBody>
-        </p:sp>
-        <p:sp>
-          <p:nvSpPr>
-            <p:cNvPr id="23" name="rc23"/>
-            <p:cNvSpPr/>
-            <p:nvPr/>
-          </p:nvSpPr>
-          <p:spPr>
-            <a:xfrm>
-              <a:off x="2388243" y="2685728"/>
-              <a:ext cx="648339" cy="648339"/>
-            </a:xfrm>
-            <a:prstGeom prst="rect">
-              <a:avLst/>
-            </a:prstGeom>
-            <a:solidFill>
-              <a:srgbClr val="FCFDBF">
-                <a:alpha val="100000"/>
-              </a:srgbClr>
-            </a:solidFill>
-            <a:ln w="5420" cap="flat">
-              <a:solidFill>
-                <a:srgbClr val="FFFFFF">
-                  <a:alpha val="100000"/>
-                </a:srgbClr>
-              </a:solidFill>
-              <a:prstDash val="solid"/>
-              <a:miter/>
-            </a:ln>
-          </p:spPr>
-          <p:txBody>
-            <a:bodyPr/>
-            <a:lstStyle/>
-            <a:p/>
-          </p:txBody>
-        </p:sp>
-        <p:sp>
-          <p:nvSpPr>
-            <p:cNvPr id="24" name="rc24"/>
-            <p:cNvSpPr/>
-            <p:nvPr/>
-          </p:nvSpPr>
-          <p:spPr>
-            <a:xfrm>
-              <a:off x="3036582" y="3982407"/>
-              <a:ext cx="648339" cy="648339"/>
-            </a:xfrm>
-            <a:prstGeom prst="rect">
-              <a:avLst/>
-            </a:prstGeom>
-            <a:solidFill>
-              <a:srgbClr val="FEB67C">
-                <a:alpha val="100000"/>
-              </a:srgbClr>
-            </a:solidFill>
-            <a:ln w="5420" cap="flat">
-              <a:solidFill>
-                <a:srgbClr val="FFFFFF">
-                  <a:alpha val="100000"/>
-                </a:srgbClr>
-              </a:solidFill>
-              <a:prstDash val="solid"/>
-              <a:miter/>
-            </a:ln>
-          </p:spPr>
-          <p:txBody>
-            <a:bodyPr/>
-            <a:lstStyle/>
-            <a:p/>
-          </p:txBody>
-        </p:sp>
-        <p:sp>
-          <p:nvSpPr>
             <p:cNvPr id="25" name="rc25"/>
             <p:cNvSpPr/>
             <p:nvPr/>
           </p:nvSpPr>
           <p:spPr>
             <a:xfrm>
-              <a:off x="3036582" y="3334068"/>
-              <a:ext cx="648339" cy="648339"/>
-            </a:xfrm>
-            <a:prstGeom prst="rect">
-              <a:avLst/>
-            </a:prstGeom>
-            <a:solidFill>
-              <a:srgbClr val="FDE3A5">
-                <a:alpha val="100000"/>
-              </a:srgbClr>
-            </a:solidFill>
-            <a:ln w="5420" cap="flat">
-              <a:solidFill>
-                <a:srgbClr val="FFFFFF">
-                  <a:alpha val="100000"/>
-                </a:srgbClr>
-              </a:solidFill>
-              <a:prstDash val="solid"/>
-              <a:miter/>
-            </a:ln>
-          </p:spPr>
-          <p:txBody>
-            <a:bodyPr/>
-            <a:lstStyle/>
-            <a:p/>
-          </p:txBody>
-        </p:sp>
-        <p:sp>
-          <p:nvSpPr>
-            <p:cNvPr id="26" name="rc26"/>
-            <p:cNvSpPr/>
-            <p:nvPr/>
-          </p:nvSpPr>
-          <p:spPr>
-            <a:xfrm>
-              <a:off x="3036582" y="2685728"/>
-              <a:ext cx="648339" cy="648339"/>
-            </a:xfrm>
-            <a:prstGeom prst="rect">
-              <a:avLst/>
-            </a:prstGeom>
-            <a:solidFill>
-              <a:srgbClr val="FCFDBF">
-                <a:alpha val="100000"/>
-              </a:srgbClr>
-            </a:solidFill>
-            <a:ln w="5420" cap="flat">
-              <a:solidFill>
-                <a:srgbClr val="FFFFFF">
-                  <a:alpha val="100000"/>
-                </a:srgbClr>
-              </a:solidFill>
-              <a:prstDash val="solid"/>
-              <a:miter/>
-            </a:ln>
-          </p:spPr>
-          <p:txBody>
-            <a:bodyPr/>
-            <a:lstStyle/>
-            <a:p/>
-          </p:txBody>
-        </p:sp>
-        <p:sp>
-          <p:nvSpPr>
-            <p:cNvPr id="27" name="rc27"/>
-            <p:cNvSpPr/>
-            <p:nvPr/>
-          </p:nvSpPr>
-          <p:spPr>
-            <a:xfrm>
-              <a:off x="4981602" y="3982407"/>
-              <a:ext cx="648339" cy="648339"/>
-            </a:xfrm>
-            <a:prstGeom prst="rect">
-              <a:avLst/>
-            </a:prstGeom>
-            <a:solidFill>
-              <a:srgbClr val="0A0822">
-                <a:alpha val="100000"/>
-              </a:srgbClr>
-            </a:solidFill>
-            <a:ln w="5420" cap="flat">
-              <a:solidFill>
-                <a:srgbClr val="FFFFFF">
-                  <a:alpha val="100000"/>
-                </a:srgbClr>
-              </a:solidFill>
-              <a:prstDash val="solid"/>
-              <a:miter/>
-            </a:ln>
-          </p:spPr>
-          <p:txBody>
-            <a:bodyPr/>
-            <a:lstStyle/>
-            <a:p/>
-          </p:txBody>
-        </p:sp>
-        <p:sp>
-          <p:nvSpPr>
-            <p:cNvPr id="28" name="rc28"/>
-            <p:cNvSpPr/>
-            <p:nvPr/>
-          </p:nvSpPr>
-          <p:spPr>
-            <a:xfrm>
-              <a:off x="4981602" y="3334068"/>
-              <a:ext cx="648339" cy="648339"/>
-            </a:xfrm>
-            <a:prstGeom prst="rect">
-              <a:avLst/>
-            </a:prstGeom>
-            <a:solidFill>
-              <a:srgbClr val="F1605D">
-                <a:alpha val="100000"/>
-              </a:srgbClr>
-            </a:solidFill>
-            <a:ln w="5420" cap="flat">
-              <a:solidFill>
-                <a:srgbClr val="FFFFFF">
-                  <a:alpha val="100000"/>
-                </a:srgbClr>
-              </a:solidFill>
-              <a:prstDash val="solid"/>
-              <a:miter/>
-            </a:ln>
-          </p:spPr>
-          <p:txBody>
-            <a:bodyPr/>
-            <a:lstStyle/>
-            <a:p/>
-          </p:txBody>
-        </p:sp>
-        <p:sp>
-          <p:nvSpPr>
-            <p:cNvPr id="29" name="rc29"/>
-            <p:cNvSpPr/>
-            <p:nvPr/>
-          </p:nvSpPr>
-          <p:spPr>
-            <a:xfrm>
-              <a:off x="4981602" y="2685728"/>
-              <a:ext cx="648339" cy="648339"/>
-            </a:xfrm>
-            <a:prstGeom prst="rect">
-              <a:avLst/>
-            </a:prstGeom>
-            <a:solidFill>
-              <a:srgbClr val="FCFDBF">
-                <a:alpha val="100000"/>
-              </a:srgbClr>
-            </a:solidFill>
-            <a:ln w="5420" cap="flat">
-              <a:solidFill>
-                <a:srgbClr val="FFFFFF">
-                  <a:alpha val="100000"/>
-                </a:srgbClr>
-              </a:solidFill>
-              <a:prstDash val="solid"/>
-              <a:miter/>
-            </a:ln>
-          </p:spPr>
-          <p:txBody>
-            <a:bodyPr/>
-            <a:lstStyle/>
-            <a:p/>
-          </p:txBody>
-        </p:sp>
-        <p:sp>
-          <p:nvSpPr>
-            <p:cNvPr id="30" name="rc30"/>
-            <p:cNvSpPr/>
-            <p:nvPr/>
-          </p:nvSpPr>
-          <p:spPr>
-            <a:xfrm>
-              <a:off x="5629942" y="3982407"/>
-              <a:ext cx="648339" cy="648339"/>
-            </a:xfrm>
-            <a:prstGeom prst="rect">
-              <a:avLst/>
-            </a:prstGeom>
-            <a:solidFill>
-              <a:srgbClr val="FCFDBF">
-                <a:alpha val="100000"/>
-              </a:srgbClr>
-            </a:solidFill>
-            <a:ln w="5420" cap="flat">
-              <a:solidFill>
-                <a:srgbClr val="FFFFFF">
-                  <a:alpha val="100000"/>
-                </a:srgbClr>
-              </a:solidFill>
-              <a:prstDash val="solid"/>
-              <a:miter/>
-            </a:ln>
-          </p:spPr>
-          <p:txBody>
-            <a:bodyPr/>
-            <a:lstStyle/>
-            <a:p/>
-          </p:txBody>
-        </p:sp>
-        <p:sp>
-          <p:nvSpPr>
-            <p:cNvPr id="31" name="rc31"/>
-            <p:cNvSpPr/>
-            <p:nvPr/>
-          </p:nvSpPr>
-          <p:spPr>
-            <a:xfrm>
-              <a:off x="5629942" y="3334068"/>
-              <a:ext cx="648339" cy="648339"/>
-            </a:xfrm>
-            <a:prstGeom prst="rect">
-              <a:avLst/>
-            </a:prstGeom>
-            <a:solidFill>
-              <a:srgbClr val="FEBA80">
-                <a:alpha val="100000"/>
-              </a:srgbClr>
-            </a:solidFill>
-            <a:ln w="5420" cap="flat">
-              <a:solidFill>
-                <a:srgbClr val="FFFFFF">
-                  <a:alpha val="100000"/>
-                </a:srgbClr>
-              </a:solidFill>
-              <a:prstDash val="solid"/>
-              <a:miter/>
-            </a:ln>
-          </p:spPr>
-          <p:txBody>
-            <a:bodyPr/>
-            <a:lstStyle/>
-            <a:p/>
-          </p:txBody>
-        </p:sp>
-        <p:sp>
-          <p:nvSpPr>
-            <p:cNvPr id="32" name="rc32"/>
-            <p:cNvSpPr/>
-            <p:nvPr/>
-          </p:nvSpPr>
-          <p:spPr>
-            <a:xfrm>
-              <a:off x="5629942" y="2685728"/>
-              <a:ext cx="648339" cy="648339"/>
-            </a:xfrm>
-            <a:prstGeom prst="rect">
-              <a:avLst/>
-            </a:prstGeom>
-            <a:solidFill>
-              <a:srgbClr val="FCFDBF">
-                <a:alpha val="100000"/>
-              </a:srgbClr>
-            </a:solidFill>
-            <a:ln w="5420" cap="flat">
-              <a:solidFill>
-                <a:srgbClr val="FFFFFF">
-                  <a:alpha val="100000"/>
-                </a:srgbClr>
-              </a:solidFill>
-              <a:prstDash val="solid"/>
-              <a:miter/>
-            </a:ln>
-          </p:spPr>
-          <p:txBody>
-            <a:bodyPr/>
-            <a:lstStyle/>
-            <a:p/>
-          </p:txBody>
-        </p:sp>
-        <p:sp>
-          <p:nvSpPr>
-            <p:cNvPr id="33" name="rc33"/>
-            <p:cNvSpPr/>
-            <p:nvPr/>
-          </p:nvSpPr>
-          <p:spPr>
-            <a:xfrm>
-              <a:off x="6926622" y="3982407"/>
-              <a:ext cx="648339" cy="648339"/>
-            </a:xfrm>
-            <a:prstGeom prst="rect">
-              <a:avLst/>
-            </a:prstGeom>
-            <a:solidFill>
-              <a:srgbClr val="772281">
-                <a:alpha val="100000"/>
-              </a:srgbClr>
-            </a:solidFill>
-            <a:ln w="5420" cap="flat">
-              <a:solidFill>
-                <a:srgbClr val="FFFFFF">
-                  <a:alpha val="100000"/>
-                </a:srgbClr>
-              </a:solidFill>
-              <a:prstDash val="solid"/>
-              <a:miter/>
-            </a:ln>
-          </p:spPr>
-          <p:txBody>
-            <a:bodyPr/>
-            <a:lstStyle/>
-            <a:p/>
-          </p:txBody>
-        </p:sp>
-        <p:sp>
-          <p:nvSpPr>
-            <p:cNvPr id="34" name="rc34"/>
-            <p:cNvSpPr/>
-            <p:nvPr/>
-          </p:nvSpPr>
-          <p:spPr>
-            <a:xfrm>
-              <a:off x="6926622" y="3334068"/>
-              <a:ext cx="648339" cy="648339"/>
+              <a:off x="6911869" y="2996486"/>
+              <a:ext cx="661751" cy="661751"/>
             </a:xfrm>
             <a:prstGeom prst="rect">
               <a:avLst/>
@@ -6514,48 +6199,13 @@
         </p:sp>
         <p:sp>
           <p:nvSpPr>
-            <p:cNvPr id="35" name="rc35"/>
-            <p:cNvSpPr/>
-            <p:nvPr/>
-          </p:nvSpPr>
-          <p:spPr>
-            <a:xfrm>
-              <a:off x="6926622" y="2685728"/>
-              <a:ext cx="648339" cy="648339"/>
-            </a:xfrm>
-            <a:prstGeom prst="rect">
-              <a:avLst/>
-            </a:prstGeom>
-            <a:solidFill>
-              <a:srgbClr val="BB3978">
-                <a:alpha val="100000"/>
-              </a:srgbClr>
-            </a:solidFill>
-            <a:ln w="5420" cap="flat">
-              <a:solidFill>
-                <a:srgbClr val="FFFFFF">
-                  <a:alpha val="100000"/>
-                </a:srgbClr>
-              </a:solidFill>
-              <a:prstDash val="solid"/>
-              <a:miter/>
-            </a:ln>
-          </p:spPr>
-          <p:txBody>
-            <a:bodyPr/>
-            <a:lstStyle/>
-            <a:p/>
-          </p:txBody>
-        </p:sp>
-        <p:sp>
-          <p:nvSpPr>
-            <p:cNvPr id="36" name="tx36"/>
-            <p:cNvSpPr/>
-            <p:nvPr/>
-          </p:nvSpPr>
-          <p:spPr>
-            <a:xfrm>
-              <a:off x="6466480" y="4256468"/>
+            <p:cNvPr id="26" name="tx26"/>
+            <p:cNvSpPr/>
+            <p:nvPr/>
+          </p:nvSpPr>
+          <p:spPr>
+            <a:xfrm>
+              <a:off x="6445023" y="3939004"/>
               <a:ext cx="271942" cy="100218"/>
             </a:xfrm>
             <a:prstGeom prst="rect">
@@ -6595,13 +6245,13 @@
         </p:sp>
         <p:sp>
           <p:nvSpPr>
-            <p:cNvPr id="37" name="tx37"/>
-            <p:cNvSpPr/>
-            <p:nvPr/>
-          </p:nvSpPr>
-          <p:spPr>
-            <a:xfrm>
-              <a:off x="6563590" y="3608128"/>
+            <p:cNvPr id="27" name="tx27"/>
+            <p:cNvSpPr/>
+            <p:nvPr/>
+          </p:nvSpPr>
+          <p:spPr>
+            <a:xfrm>
+              <a:off x="6542132" y="3277253"/>
               <a:ext cx="77724" cy="100218"/>
             </a:xfrm>
             <a:prstGeom prst="rect">
@@ -6641,13 +6291,59 @@
         </p:sp>
         <p:sp>
           <p:nvSpPr>
-            <p:cNvPr id="38" name="tx38"/>
-            <p:cNvSpPr/>
-            <p:nvPr/>
-          </p:nvSpPr>
-          <p:spPr>
-            <a:xfrm>
-              <a:off x="6563590" y="2959789"/>
+            <p:cNvPr id="28" name="tx28"/>
+            <p:cNvSpPr/>
+            <p:nvPr/>
+          </p:nvSpPr>
+          <p:spPr>
+            <a:xfrm>
+              <a:off x="3798018" y="3939004"/>
+              <a:ext cx="271942" cy="100218"/>
+            </a:xfrm>
+            <a:prstGeom prst="rect">
+              <a:avLst/>
+            </a:prstGeom>
+            <a:noFill/>
+          </p:spPr>
+          <p:txBody>
+            <a:bodyPr lIns="0" rIns="0" tIns="0" bIns="0" anchorCtr="1" anchor="ctr" wrap="none"/>
+            <a:lstStyle/>
+            <a:p>
+              <a:pPr algn="l" marL="0" marR="0" indent="0">
+                <a:lnSpc>
+                  <a:spcPts val="1100"/>
+                </a:lnSpc>
+                <a:spcBef>
+                  <a:spcPts val="0"/>
+                </a:spcBef>
+                <a:spcAft>
+                  <a:spcPts val="0"/>
+                </a:spcAft>
+              </a:pPr>
+              <a:r>
+                <a:rPr sz="1100">
+                  <a:solidFill>
+                    <a:srgbClr val="000000">
+                      <a:alpha val="100000"/>
+                    </a:srgbClr>
+                  </a:solidFill>
+                  <a:latin typeface="Helvetica"/>
+                  <a:cs typeface="Helvetica"/>
+                </a:rPr>
+                <a:t>0.35</a:t>
+              </a:r>
+            </a:p>
+          </p:txBody>
+        </p:sp>
+        <p:sp>
+          <p:nvSpPr>
+            <p:cNvPr id="29" name="tx29"/>
+            <p:cNvSpPr/>
+            <p:nvPr/>
+          </p:nvSpPr>
+          <p:spPr>
+            <a:xfrm>
+              <a:off x="3895128" y="3277253"/>
               <a:ext cx="77724" cy="100218"/>
             </a:xfrm>
             <a:prstGeom prst="rect">
@@ -6687,13 +6383,59 @@
         </p:sp>
         <p:sp>
           <p:nvSpPr>
-            <p:cNvPr id="39" name="tx39"/>
-            <p:cNvSpPr/>
-            <p:nvPr/>
-          </p:nvSpPr>
-          <p:spPr>
-            <a:xfrm>
-              <a:off x="3873121" y="4256468"/>
+            <p:cNvPr id="30" name="tx30"/>
+            <p:cNvSpPr/>
+            <p:nvPr/>
+          </p:nvSpPr>
+          <p:spPr>
+            <a:xfrm>
+              <a:off x="4459769" y="3939004"/>
+              <a:ext cx="271942" cy="100218"/>
+            </a:xfrm>
+            <a:prstGeom prst="rect">
+              <a:avLst/>
+            </a:prstGeom>
+            <a:noFill/>
+          </p:spPr>
+          <p:txBody>
+            <a:bodyPr lIns="0" rIns="0" tIns="0" bIns="0" anchorCtr="1" anchor="ctr" wrap="none"/>
+            <a:lstStyle/>
+            <a:p>
+              <a:pPr algn="l" marL="0" marR="0" indent="0">
+                <a:lnSpc>
+                  <a:spcPts val="1100"/>
+                </a:lnSpc>
+                <a:spcBef>
+                  <a:spcPts val="0"/>
+                </a:spcBef>
+                <a:spcAft>
+                  <a:spcPts val="0"/>
+                </a:spcAft>
+              </a:pPr>
+              <a:r>
+                <a:rPr sz="1100">
+                  <a:solidFill>
+                    <a:srgbClr val="FFFFFF">
+                      <a:alpha val="100000"/>
+                    </a:srgbClr>
+                  </a:solidFill>
+                  <a:latin typeface="Helvetica"/>
+                  <a:cs typeface="Helvetica"/>
+                </a:rPr>
+                <a:t>0.65</a:t>
+              </a:r>
+            </a:p>
+          </p:txBody>
+        </p:sp>
+        <p:sp>
+          <p:nvSpPr>
+            <p:cNvPr id="31" name="tx31"/>
+            <p:cNvSpPr/>
+            <p:nvPr/>
+          </p:nvSpPr>
+          <p:spPr>
+            <a:xfrm>
+              <a:off x="4459769" y="3277253"/>
               <a:ext cx="271942" cy="100218"/>
             </a:xfrm>
             <a:prstGeom prst="rect">
@@ -6726,20 +6468,66 @@
                   <a:latin typeface="Helvetica"/>
                   <a:cs typeface="Helvetica"/>
                 </a:rPr>
-                <a:t>0.35</a:t>
+                <a:t>0.14</a:t>
               </a:r>
             </a:p>
           </p:txBody>
         </p:sp>
         <p:sp>
           <p:nvSpPr>
-            <p:cNvPr id="40" name="tx40"/>
-            <p:cNvSpPr/>
-            <p:nvPr/>
-          </p:nvSpPr>
-          <p:spPr>
-            <a:xfrm>
-              <a:off x="3970230" y="3608128"/>
+            <p:cNvPr id="32" name="tx32"/>
+            <p:cNvSpPr/>
+            <p:nvPr/>
+          </p:nvSpPr>
+          <p:spPr>
+            <a:xfrm>
+              <a:off x="1151014" y="3939004"/>
+              <a:ext cx="271942" cy="100218"/>
+            </a:xfrm>
+            <a:prstGeom prst="rect">
+              <a:avLst/>
+            </a:prstGeom>
+            <a:noFill/>
+          </p:spPr>
+          <p:txBody>
+            <a:bodyPr lIns="0" rIns="0" tIns="0" bIns="0" anchorCtr="1" anchor="ctr" wrap="none"/>
+            <a:lstStyle/>
+            <a:p>
+              <a:pPr algn="l" marL="0" marR="0" indent="0">
+                <a:lnSpc>
+                  <a:spcPts val="1100"/>
+                </a:lnSpc>
+                <a:spcBef>
+                  <a:spcPts val="0"/>
+                </a:spcBef>
+                <a:spcAft>
+                  <a:spcPts val="0"/>
+                </a:spcAft>
+              </a:pPr>
+              <a:r>
+                <a:rPr sz="1100">
+                  <a:solidFill>
+                    <a:srgbClr val="FFFFFF">
+                      <a:alpha val="100000"/>
+                    </a:srgbClr>
+                  </a:solidFill>
+                  <a:latin typeface="Helvetica"/>
+                  <a:cs typeface="Helvetica"/>
+                </a:rPr>
+                <a:t>0.67</a:t>
+              </a:r>
+            </a:p>
+          </p:txBody>
+        </p:sp>
+        <p:sp>
+          <p:nvSpPr>
+            <p:cNvPr id="33" name="tx33"/>
+            <p:cNvSpPr/>
+            <p:nvPr/>
+          </p:nvSpPr>
+          <p:spPr>
+            <a:xfrm>
+              <a:off x="1248123" y="3277253"/>
               <a:ext cx="77724" cy="100218"/>
             </a:xfrm>
             <a:prstGeom prst="rect">
@@ -6779,13 +6567,59 @@
         </p:sp>
         <p:sp>
           <p:nvSpPr>
-            <p:cNvPr id="41" name="tx41"/>
-            <p:cNvSpPr/>
-            <p:nvPr/>
-          </p:nvSpPr>
-          <p:spPr>
-            <a:xfrm>
-              <a:off x="3970230" y="2959789"/>
+            <p:cNvPr id="34" name="tx34"/>
+            <p:cNvSpPr/>
+            <p:nvPr/>
+          </p:nvSpPr>
+          <p:spPr>
+            <a:xfrm>
+              <a:off x="1812765" y="3939004"/>
+              <a:ext cx="271942" cy="100218"/>
+            </a:xfrm>
+            <a:prstGeom prst="rect">
+              <a:avLst/>
+            </a:prstGeom>
+            <a:noFill/>
+          </p:spPr>
+          <p:txBody>
+            <a:bodyPr lIns="0" rIns="0" tIns="0" bIns="0" anchorCtr="1" anchor="ctr" wrap="none"/>
+            <a:lstStyle/>
+            <a:p>
+              <a:pPr algn="l" marL="0" marR="0" indent="0">
+                <a:lnSpc>
+                  <a:spcPts val="1100"/>
+                </a:lnSpc>
+                <a:spcBef>
+                  <a:spcPts val="0"/>
+                </a:spcBef>
+                <a:spcAft>
+                  <a:spcPts val="0"/>
+                </a:spcAft>
+              </a:pPr>
+              <a:r>
+                <a:rPr sz="1100">
+                  <a:solidFill>
+                    <a:srgbClr val="000000">
+                      <a:alpha val="100000"/>
+                    </a:srgbClr>
+                  </a:solidFill>
+                  <a:latin typeface="Helvetica"/>
+                  <a:cs typeface="Helvetica"/>
+                </a:rPr>
+                <a:t>0.39</a:t>
+              </a:r>
+            </a:p>
+          </p:txBody>
+        </p:sp>
+        <p:sp>
+          <p:nvSpPr>
+            <p:cNvPr id="35" name="tx35"/>
+            <p:cNvSpPr/>
+            <p:nvPr/>
+          </p:nvSpPr>
+          <p:spPr>
+            <a:xfrm>
+              <a:off x="1909874" y="3277253"/>
               <a:ext cx="77724" cy="100218"/>
             </a:xfrm>
             <a:prstGeom prst="rect">
@@ -6825,13 +6659,381 @@
         </p:sp>
         <p:sp>
           <p:nvSpPr>
+            <p:cNvPr id="36" name="tx36"/>
+            <p:cNvSpPr/>
+            <p:nvPr/>
+          </p:nvSpPr>
+          <p:spPr>
+            <a:xfrm>
+              <a:off x="2474516" y="3939004"/>
+              <a:ext cx="271942" cy="100218"/>
+            </a:xfrm>
+            <a:prstGeom prst="rect">
+              <a:avLst/>
+            </a:prstGeom>
+            <a:noFill/>
+          </p:spPr>
+          <p:txBody>
+            <a:bodyPr lIns="0" rIns="0" tIns="0" bIns="0" anchorCtr="1" anchor="ctr" wrap="none"/>
+            <a:lstStyle/>
+            <a:p>
+              <a:pPr algn="l" marL="0" marR="0" indent="0">
+                <a:lnSpc>
+                  <a:spcPts val="1100"/>
+                </a:lnSpc>
+                <a:spcBef>
+                  <a:spcPts val="0"/>
+                </a:spcBef>
+                <a:spcAft>
+                  <a:spcPts val="0"/>
+                </a:spcAft>
+              </a:pPr>
+              <a:r>
+                <a:rPr sz="1100">
+                  <a:solidFill>
+                    <a:srgbClr val="FFFFFF">
+                      <a:alpha val="100000"/>
+                    </a:srgbClr>
+                  </a:solidFill>
+                  <a:latin typeface="Helvetica"/>
+                  <a:cs typeface="Helvetica"/>
+                </a:rPr>
+                <a:t>0.95</a:t>
+              </a:r>
+            </a:p>
+          </p:txBody>
+        </p:sp>
+        <p:sp>
+          <p:nvSpPr>
+            <p:cNvPr id="37" name="tx37"/>
+            <p:cNvSpPr/>
+            <p:nvPr/>
+          </p:nvSpPr>
+          <p:spPr>
+            <a:xfrm>
+              <a:off x="2571625" y="3277253"/>
+              <a:ext cx="77724" cy="100218"/>
+            </a:xfrm>
+            <a:prstGeom prst="rect">
+              <a:avLst/>
+            </a:prstGeom>
+            <a:noFill/>
+          </p:spPr>
+          <p:txBody>
+            <a:bodyPr lIns="0" rIns="0" tIns="0" bIns="0" anchorCtr="1" anchor="ctr" wrap="none"/>
+            <a:lstStyle/>
+            <a:p>
+              <a:pPr algn="l" marL="0" marR="0" indent="0">
+                <a:lnSpc>
+                  <a:spcPts val="1100"/>
+                </a:lnSpc>
+                <a:spcBef>
+                  <a:spcPts val="0"/>
+                </a:spcBef>
+                <a:spcAft>
+                  <a:spcPts val="0"/>
+                </a:spcAft>
+              </a:pPr>
+              <a:r>
+                <a:rPr sz="1100">
+                  <a:solidFill>
+                    <a:srgbClr val="000000">
+                      <a:alpha val="100000"/>
+                    </a:srgbClr>
+                  </a:solidFill>
+                  <a:latin typeface="Helvetica"/>
+                  <a:cs typeface="Helvetica"/>
+                </a:rPr>
+                <a:t>0</a:t>
+              </a:r>
+            </a:p>
+          </p:txBody>
+        </p:sp>
+        <p:sp>
+          <p:nvSpPr>
+            <p:cNvPr id="38" name="tx38"/>
+            <p:cNvSpPr/>
+            <p:nvPr/>
+          </p:nvSpPr>
+          <p:spPr>
+            <a:xfrm>
+              <a:off x="3136267" y="3939004"/>
+              <a:ext cx="271942" cy="100218"/>
+            </a:xfrm>
+            <a:prstGeom prst="rect">
+              <a:avLst/>
+            </a:prstGeom>
+            <a:noFill/>
+          </p:spPr>
+          <p:txBody>
+            <a:bodyPr lIns="0" rIns="0" tIns="0" bIns="0" anchorCtr="1" anchor="ctr" wrap="none"/>
+            <a:lstStyle/>
+            <a:p>
+              <a:pPr algn="l" marL="0" marR="0" indent="0">
+                <a:lnSpc>
+                  <a:spcPts val="1100"/>
+                </a:lnSpc>
+                <a:spcBef>
+                  <a:spcPts val="0"/>
+                </a:spcBef>
+                <a:spcAft>
+                  <a:spcPts val="0"/>
+                </a:spcAft>
+              </a:pPr>
+              <a:r>
+                <a:rPr sz="1100">
+                  <a:solidFill>
+                    <a:srgbClr val="000000">
+                      <a:alpha val="100000"/>
+                    </a:srgbClr>
+                  </a:solidFill>
+                  <a:latin typeface="Helvetica"/>
+                  <a:cs typeface="Helvetica"/>
+                </a:rPr>
+                <a:t>0.46</a:t>
+              </a:r>
+            </a:p>
+          </p:txBody>
+        </p:sp>
+        <p:sp>
+          <p:nvSpPr>
+            <p:cNvPr id="39" name="tx39"/>
+            <p:cNvSpPr/>
+            <p:nvPr/>
+          </p:nvSpPr>
+          <p:spPr>
+            <a:xfrm>
+              <a:off x="3136267" y="3277253"/>
+              <a:ext cx="271942" cy="100218"/>
+            </a:xfrm>
+            <a:prstGeom prst="rect">
+              <a:avLst/>
+            </a:prstGeom>
+            <a:noFill/>
+          </p:spPr>
+          <p:txBody>
+            <a:bodyPr lIns="0" rIns="0" tIns="0" bIns="0" anchorCtr="1" anchor="ctr" wrap="none"/>
+            <a:lstStyle/>
+            <a:p>
+              <a:pPr algn="l" marL="0" marR="0" indent="0">
+                <a:lnSpc>
+                  <a:spcPts val="1100"/>
+                </a:lnSpc>
+                <a:spcBef>
+                  <a:spcPts val="0"/>
+                </a:spcBef>
+                <a:spcAft>
+                  <a:spcPts val="0"/>
+                </a:spcAft>
+              </a:pPr>
+              <a:r>
+                <a:rPr sz="1100">
+                  <a:solidFill>
+                    <a:srgbClr val="000000">
+                      <a:alpha val="100000"/>
+                    </a:srgbClr>
+                  </a:solidFill>
+                  <a:latin typeface="Helvetica"/>
+                  <a:cs typeface="Helvetica"/>
+                </a:rPr>
+                <a:t>0.06</a:t>
+              </a:r>
+            </a:p>
+          </p:txBody>
+        </p:sp>
+        <p:sp>
+          <p:nvSpPr>
+            <p:cNvPr id="40" name="tx40"/>
+            <p:cNvSpPr/>
+            <p:nvPr/>
+          </p:nvSpPr>
+          <p:spPr>
+            <a:xfrm>
+              <a:off x="5121520" y="3939004"/>
+              <a:ext cx="271942" cy="100218"/>
+            </a:xfrm>
+            <a:prstGeom prst="rect">
+              <a:avLst/>
+            </a:prstGeom>
+            <a:noFill/>
+          </p:spPr>
+          <p:txBody>
+            <a:bodyPr lIns="0" rIns="0" tIns="0" bIns="0" anchorCtr="1" anchor="ctr" wrap="none"/>
+            <a:lstStyle/>
+            <a:p>
+              <a:pPr algn="l" marL="0" marR="0" indent="0">
+                <a:lnSpc>
+                  <a:spcPts val="1100"/>
+                </a:lnSpc>
+                <a:spcBef>
+                  <a:spcPts val="0"/>
+                </a:spcBef>
+                <a:spcAft>
+                  <a:spcPts val="0"/>
+                </a:spcAft>
+              </a:pPr>
+              <a:r>
+                <a:rPr sz="1100">
+                  <a:solidFill>
+                    <a:srgbClr val="FFFFFF">
+                      <a:alpha val="100000"/>
+                    </a:srgbClr>
+                  </a:solidFill>
+                  <a:latin typeface="Helvetica"/>
+                  <a:cs typeface="Helvetica"/>
+                </a:rPr>
+                <a:t>0.94</a:t>
+              </a:r>
+            </a:p>
+          </p:txBody>
+        </p:sp>
+        <p:sp>
+          <p:nvSpPr>
+            <p:cNvPr id="41" name="tx41"/>
+            <p:cNvSpPr/>
+            <p:nvPr/>
+          </p:nvSpPr>
+          <p:spPr>
+            <a:xfrm>
+              <a:off x="5121520" y="3277253"/>
+              <a:ext cx="271942" cy="100218"/>
+            </a:xfrm>
+            <a:prstGeom prst="rect">
+              <a:avLst/>
+            </a:prstGeom>
+            <a:noFill/>
+          </p:spPr>
+          <p:txBody>
+            <a:bodyPr lIns="0" rIns="0" tIns="0" bIns="0" anchorCtr="1" anchor="ctr" wrap="none"/>
+            <a:lstStyle/>
+            <a:p>
+              <a:pPr algn="l" marL="0" marR="0" indent="0">
+                <a:lnSpc>
+                  <a:spcPts val="1100"/>
+                </a:lnSpc>
+                <a:spcBef>
+                  <a:spcPts val="0"/>
+                </a:spcBef>
+                <a:spcAft>
+                  <a:spcPts val="0"/>
+                </a:spcAft>
+              </a:pPr>
+              <a:r>
+                <a:rPr sz="1100">
+                  <a:solidFill>
+                    <a:srgbClr val="000000">
+                      <a:alpha val="100000"/>
+                    </a:srgbClr>
+                  </a:solidFill>
+                  <a:latin typeface="Helvetica"/>
+                  <a:cs typeface="Helvetica"/>
+                </a:rPr>
+                <a:t>0.33</a:t>
+              </a:r>
+            </a:p>
+          </p:txBody>
+        </p:sp>
+        <p:sp>
+          <p:nvSpPr>
             <p:cNvPr id="42" name="tx42"/>
             <p:cNvSpPr/>
             <p:nvPr/>
           </p:nvSpPr>
           <p:spPr>
             <a:xfrm>
-              <a:off x="4521461" y="4256468"/>
+              <a:off x="5783271" y="3939004"/>
+              <a:ext cx="271942" cy="100218"/>
+            </a:xfrm>
+            <a:prstGeom prst="rect">
+              <a:avLst/>
+            </a:prstGeom>
+            <a:noFill/>
+          </p:spPr>
+          <p:txBody>
+            <a:bodyPr lIns="0" rIns="0" tIns="0" bIns="0" anchorCtr="1" anchor="ctr" wrap="none"/>
+            <a:lstStyle/>
+            <a:p>
+              <a:pPr algn="l" marL="0" marR="0" indent="0">
+                <a:lnSpc>
+                  <a:spcPts val="1100"/>
+                </a:lnSpc>
+                <a:spcBef>
+                  <a:spcPts val="0"/>
+                </a:spcBef>
+                <a:spcAft>
+                  <a:spcPts val="0"/>
+                </a:spcAft>
+              </a:pPr>
+              <a:r>
+                <a:rPr sz="1100">
+                  <a:solidFill>
+                    <a:srgbClr val="000000">
+                      <a:alpha val="100000"/>
+                    </a:srgbClr>
+                  </a:solidFill>
+                  <a:latin typeface="Helvetica"/>
+                  <a:cs typeface="Helvetica"/>
+                </a:rPr>
+                <a:t>0.12</a:t>
+              </a:r>
+            </a:p>
+          </p:txBody>
+        </p:sp>
+        <p:sp>
+          <p:nvSpPr>
+            <p:cNvPr id="43" name="tx43"/>
+            <p:cNvSpPr/>
+            <p:nvPr/>
+          </p:nvSpPr>
+          <p:spPr>
+            <a:xfrm>
+              <a:off x="5783271" y="3277253"/>
+              <a:ext cx="271942" cy="100218"/>
+            </a:xfrm>
+            <a:prstGeom prst="rect">
+              <a:avLst/>
+            </a:prstGeom>
+            <a:noFill/>
+          </p:spPr>
+          <p:txBody>
+            <a:bodyPr lIns="0" rIns="0" tIns="0" bIns="0" anchorCtr="1" anchor="ctr" wrap="none"/>
+            <a:lstStyle/>
+            <a:p>
+              <a:pPr algn="l" marL="0" marR="0" indent="0">
+                <a:lnSpc>
+                  <a:spcPts val="1100"/>
+                </a:lnSpc>
+                <a:spcBef>
+                  <a:spcPts val="0"/>
+                </a:spcBef>
+                <a:spcAft>
+                  <a:spcPts val="0"/>
+                </a:spcAft>
+              </a:pPr>
+              <a:r>
+                <a:rPr sz="1100">
+                  <a:solidFill>
+                    <a:srgbClr val="000000">
+                      <a:alpha val="100000"/>
+                    </a:srgbClr>
+                  </a:solidFill>
+                  <a:latin typeface="Helvetica"/>
+                  <a:cs typeface="Helvetica"/>
+                </a:rPr>
+                <a:t>0.14</a:t>
+              </a:r>
+            </a:p>
+          </p:txBody>
+        </p:sp>
+        <p:sp>
+          <p:nvSpPr>
+            <p:cNvPr id="44" name="tx44"/>
+            <p:cNvSpPr/>
+            <p:nvPr/>
+          </p:nvSpPr>
+          <p:spPr>
+            <a:xfrm>
+              <a:off x="7106774" y="3939004"/>
               <a:ext cx="271942" cy="100218"/>
             </a:xfrm>
             <a:prstGeom prst="rect">
@@ -6871,979 +7073,13 @@
         </p:sp>
         <p:sp>
           <p:nvSpPr>
-            <p:cNvPr id="43" name="tx43"/>
-            <p:cNvSpPr/>
-            <p:nvPr/>
-          </p:nvSpPr>
-          <p:spPr>
-            <a:xfrm>
-              <a:off x="4521461" y="3608128"/>
-              <a:ext cx="271942" cy="100218"/>
-            </a:xfrm>
-            <a:prstGeom prst="rect">
-              <a:avLst/>
-            </a:prstGeom>
-            <a:noFill/>
-          </p:spPr>
-          <p:txBody>
-            <a:bodyPr lIns="0" rIns="0" tIns="0" bIns="0" anchorCtr="1" anchor="ctr" wrap="none"/>
-            <a:lstStyle/>
-            <a:p>
-              <a:pPr algn="l" marL="0" marR="0" indent="0">
-                <a:lnSpc>
-                  <a:spcPts val="1100"/>
-                </a:lnSpc>
-                <a:spcBef>
-                  <a:spcPts val="0"/>
-                </a:spcBef>
-                <a:spcAft>
-                  <a:spcPts val="0"/>
-                </a:spcAft>
-              </a:pPr>
-              <a:r>
-                <a:rPr sz="1100">
-                  <a:solidFill>
-                    <a:srgbClr val="000000">
-                      <a:alpha val="100000"/>
-                    </a:srgbClr>
-                  </a:solidFill>
-                  <a:latin typeface="Helvetica"/>
-                  <a:cs typeface="Helvetica"/>
-                </a:rPr>
-                <a:t>0.14</a:t>
-              </a:r>
-            </a:p>
-          </p:txBody>
-        </p:sp>
-        <p:sp>
-          <p:nvSpPr>
-            <p:cNvPr id="44" name="tx44"/>
-            <p:cNvSpPr/>
-            <p:nvPr/>
-          </p:nvSpPr>
-          <p:spPr>
-            <a:xfrm>
-              <a:off x="4521461" y="2959789"/>
-              <a:ext cx="271942" cy="100218"/>
-            </a:xfrm>
-            <a:prstGeom prst="rect">
-              <a:avLst/>
-            </a:prstGeom>
-            <a:noFill/>
-          </p:spPr>
-          <p:txBody>
-            <a:bodyPr lIns="0" rIns="0" tIns="0" bIns="0" anchorCtr="1" anchor="ctr" wrap="none"/>
-            <a:lstStyle/>
-            <a:p>
-              <a:pPr algn="l" marL="0" marR="0" indent="0">
-                <a:lnSpc>
-                  <a:spcPts val="1100"/>
-                </a:lnSpc>
-                <a:spcBef>
-                  <a:spcPts val="0"/>
-                </a:spcBef>
-                <a:spcAft>
-                  <a:spcPts val="0"/>
-                </a:spcAft>
-              </a:pPr>
-              <a:r>
-                <a:rPr sz="1100">
-                  <a:solidFill>
-                    <a:srgbClr val="000000">
-                      <a:alpha val="100000"/>
-                    </a:srgbClr>
-                  </a:solidFill>
-                  <a:latin typeface="Helvetica"/>
-                  <a:cs typeface="Helvetica"/>
-                </a:rPr>
-                <a:t>0.49</a:t>
-              </a:r>
-            </a:p>
-          </p:txBody>
-        </p:sp>
-        <p:sp>
-          <p:nvSpPr>
             <p:cNvPr id="45" name="tx45"/>
             <p:cNvSpPr/>
             <p:nvPr/>
           </p:nvSpPr>
           <p:spPr>
             <a:xfrm>
-              <a:off x="1318624" y="4256468"/>
-              <a:ext cx="194218" cy="100218"/>
-            </a:xfrm>
-            <a:prstGeom prst="rect">
-              <a:avLst/>
-            </a:prstGeom>
-            <a:noFill/>
-          </p:spPr>
-          <p:txBody>
-            <a:bodyPr lIns="0" rIns="0" tIns="0" bIns="0" anchorCtr="1" anchor="ctr" wrap="none"/>
-            <a:lstStyle/>
-            <a:p>
-              <a:pPr algn="l" marL="0" marR="0" indent="0">
-                <a:lnSpc>
-                  <a:spcPts val="1100"/>
-                </a:lnSpc>
-                <a:spcBef>
-                  <a:spcPts val="0"/>
-                </a:spcBef>
-                <a:spcAft>
-                  <a:spcPts val="0"/>
-                </a:spcAft>
-              </a:pPr>
-              <a:r>
-                <a:rPr sz="1100">
-                  <a:solidFill>
-                    <a:srgbClr val="FFFFFF">
-                      <a:alpha val="100000"/>
-                    </a:srgbClr>
-                  </a:solidFill>
-                  <a:latin typeface="Helvetica"/>
-                  <a:cs typeface="Helvetica"/>
-                </a:rPr>
-                <a:t>0.6</a:t>
-              </a:r>
-            </a:p>
-          </p:txBody>
-        </p:sp>
-        <p:sp>
-          <p:nvSpPr>
-            <p:cNvPr id="46" name="tx46"/>
-            <p:cNvSpPr/>
-            <p:nvPr/>
-          </p:nvSpPr>
-          <p:spPr>
-            <a:xfrm>
-              <a:off x="1376871" y="3608128"/>
-              <a:ext cx="77724" cy="100218"/>
-            </a:xfrm>
-            <a:prstGeom prst="rect">
-              <a:avLst/>
-            </a:prstGeom>
-            <a:noFill/>
-          </p:spPr>
-          <p:txBody>
-            <a:bodyPr lIns="0" rIns="0" tIns="0" bIns="0" anchorCtr="1" anchor="ctr" wrap="none"/>
-            <a:lstStyle/>
-            <a:p>
-              <a:pPr algn="l" marL="0" marR="0" indent="0">
-                <a:lnSpc>
-                  <a:spcPts val="1100"/>
-                </a:lnSpc>
-                <a:spcBef>
-                  <a:spcPts val="0"/>
-                </a:spcBef>
-                <a:spcAft>
-                  <a:spcPts val="0"/>
-                </a:spcAft>
-              </a:pPr>
-              <a:r>
-                <a:rPr sz="1100">
-                  <a:solidFill>
-                    <a:srgbClr val="000000">
-                      <a:alpha val="100000"/>
-                    </a:srgbClr>
-                  </a:solidFill>
-                  <a:latin typeface="Helvetica"/>
-                  <a:cs typeface="Helvetica"/>
-                </a:rPr>
-                <a:t>0</a:t>
-              </a:r>
-            </a:p>
-          </p:txBody>
-        </p:sp>
-        <p:sp>
-          <p:nvSpPr>
-            <p:cNvPr id="47" name="tx47"/>
-            <p:cNvSpPr/>
-            <p:nvPr/>
-          </p:nvSpPr>
-          <p:spPr>
-            <a:xfrm>
-              <a:off x="1376871" y="2959789"/>
-              <a:ext cx="77724" cy="100218"/>
-            </a:xfrm>
-            <a:prstGeom prst="rect">
-              <a:avLst/>
-            </a:prstGeom>
-            <a:noFill/>
-          </p:spPr>
-          <p:txBody>
-            <a:bodyPr lIns="0" rIns="0" tIns="0" bIns="0" anchorCtr="1" anchor="ctr" wrap="none"/>
-            <a:lstStyle/>
-            <a:p>
-              <a:pPr algn="l" marL="0" marR="0" indent="0">
-                <a:lnSpc>
-                  <a:spcPts val="1100"/>
-                </a:lnSpc>
-                <a:spcBef>
-                  <a:spcPts val="0"/>
-                </a:spcBef>
-                <a:spcAft>
-                  <a:spcPts val="0"/>
-                </a:spcAft>
-              </a:pPr>
-              <a:r>
-                <a:rPr sz="1100">
-                  <a:solidFill>
-                    <a:srgbClr val="000000">
-                      <a:alpha val="100000"/>
-                    </a:srgbClr>
-                  </a:solidFill>
-                  <a:latin typeface="Helvetica"/>
-                  <a:cs typeface="Helvetica"/>
-                </a:rPr>
-                <a:t>0</a:t>
-              </a:r>
-            </a:p>
-          </p:txBody>
-        </p:sp>
-        <p:sp>
-          <p:nvSpPr>
-            <p:cNvPr id="48" name="tx48"/>
-            <p:cNvSpPr/>
-            <p:nvPr/>
-          </p:nvSpPr>
-          <p:spPr>
-            <a:xfrm>
-              <a:off x="1928101" y="4256468"/>
-              <a:ext cx="271942" cy="100218"/>
-            </a:xfrm>
-            <a:prstGeom prst="rect">
-              <a:avLst/>
-            </a:prstGeom>
-            <a:noFill/>
-          </p:spPr>
-          <p:txBody>
-            <a:bodyPr lIns="0" rIns="0" tIns="0" bIns="0" anchorCtr="1" anchor="ctr" wrap="none"/>
-            <a:lstStyle/>
-            <a:p>
-              <a:pPr algn="l" marL="0" marR="0" indent="0">
-                <a:lnSpc>
-                  <a:spcPts val="1100"/>
-                </a:lnSpc>
-                <a:spcBef>
-                  <a:spcPts val="0"/>
-                </a:spcBef>
-                <a:spcAft>
-                  <a:spcPts val="0"/>
-                </a:spcAft>
-              </a:pPr>
-              <a:r>
-                <a:rPr sz="1100">
-                  <a:solidFill>
-                    <a:srgbClr val="000000">
-                      <a:alpha val="100000"/>
-                    </a:srgbClr>
-                  </a:solidFill>
-                  <a:latin typeface="Helvetica"/>
-                  <a:cs typeface="Helvetica"/>
-                </a:rPr>
-                <a:t>0.28</a:t>
-              </a:r>
-            </a:p>
-          </p:txBody>
-        </p:sp>
-        <p:sp>
-          <p:nvSpPr>
-            <p:cNvPr id="49" name="tx49"/>
-            <p:cNvSpPr/>
-            <p:nvPr/>
-          </p:nvSpPr>
-          <p:spPr>
-            <a:xfrm>
-              <a:off x="2025211" y="3608128"/>
-              <a:ext cx="77724" cy="100218"/>
-            </a:xfrm>
-            <a:prstGeom prst="rect">
-              <a:avLst/>
-            </a:prstGeom>
-            <a:noFill/>
-          </p:spPr>
-          <p:txBody>
-            <a:bodyPr lIns="0" rIns="0" tIns="0" bIns="0" anchorCtr="1" anchor="ctr" wrap="none"/>
-            <a:lstStyle/>
-            <a:p>
-              <a:pPr algn="l" marL="0" marR="0" indent="0">
-                <a:lnSpc>
-                  <a:spcPts val="1100"/>
-                </a:lnSpc>
-                <a:spcBef>
-                  <a:spcPts val="0"/>
-                </a:spcBef>
-                <a:spcAft>
-                  <a:spcPts val="0"/>
-                </a:spcAft>
-              </a:pPr>
-              <a:r>
-                <a:rPr sz="1100">
-                  <a:solidFill>
-                    <a:srgbClr val="000000">
-                      <a:alpha val="100000"/>
-                    </a:srgbClr>
-                  </a:solidFill>
-                  <a:latin typeface="Helvetica"/>
-                  <a:cs typeface="Helvetica"/>
-                </a:rPr>
-                <a:t>0</a:t>
-              </a:r>
-            </a:p>
-          </p:txBody>
-        </p:sp>
-        <p:sp>
-          <p:nvSpPr>
-            <p:cNvPr id="50" name="tx50"/>
-            <p:cNvSpPr/>
-            <p:nvPr/>
-          </p:nvSpPr>
-          <p:spPr>
-            <a:xfrm>
-              <a:off x="2025211" y="2959789"/>
-              <a:ext cx="77724" cy="100218"/>
-            </a:xfrm>
-            <a:prstGeom prst="rect">
-              <a:avLst/>
-            </a:prstGeom>
-            <a:noFill/>
-          </p:spPr>
-          <p:txBody>
-            <a:bodyPr lIns="0" rIns="0" tIns="0" bIns="0" anchorCtr="1" anchor="ctr" wrap="none"/>
-            <a:lstStyle/>
-            <a:p>
-              <a:pPr algn="l" marL="0" marR="0" indent="0">
-                <a:lnSpc>
-                  <a:spcPts val="1100"/>
-                </a:lnSpc>
-                <a:spcBef>
-                  <a:spcPts val="0"/>
-                </a:spcBef>
-                <a:spcAft>
-                  <a:spcPts val="0"/>
-                </a:spcAft>
-              </a:pPr>
-              <a:r>
-                <a:rPr sz="1100">
-                  <a:solidFill>
-                    <a:srgbClr val="000000">
-                      <a:alpha val="100000"/>
-                    </a:srgbClr>
-                  </a:solidFill>
-                  <a:latin typeface="Helvetica"/>
-                  <a:cs typeface="Helvetica"/>
-                </a:rPr>
-                <a:t>0</a:t>
-              </a:r>
-            </a:p>
-          </p:txBody>
-        </p:sp>
-        <p:sp>
-          <p:nvSpPr>
-            <p:cNvPr id="51" name="tx51"/>
-            <p:cNvSpPr/>
-            <p:nvPr/>
-          </p:nvSpPr>
-          <p:spPr>
-            <a:xfrm>
-              <a:off x="2576441" y="4256468"/>
-              <a:ext cx="271942" cy="100218"/>
-            </a:xfrm>
-            <a:prstGeom prst="rect">
-              <a:avLst/>
-            </a:prstGeom>
-            <a:noFill/>
-          </p:spPr>
-          <p:txBody>
-            <a:bodyPr lIns="0" rIns="0" tIns="0" bIns="0" anchorCtr="1" anchor="ctr" wrap="none"/>
-            <a:lstStyle/>
-            <a:p>
-              <a:pPr algn="l" marL="0" marR="0" indent="0">
-                <a:lnSpc>
-                  <a:spcPts val="1100"/>
-                </a:lnSpc>
-                <a:spcBef>
-                  <a:spcPts val="0"/>
-                </a:spcBef>
-                <a:spcAft>
-                  <a:spcPts val="0"/>
-                </a:spcAft>
-              </a:pPr>
-              <a:r>
-                <a:rPr sz="1100">
-                  <a:solidFill>
-                    <a:srgbClr val="FFFFFF">
-                      <a:alpha val="100000"/>
-                    </a:srgbClr>
-                  </a:solidFill>
-                  <a:latin typeface="Helvetica"/>
-                  <a:cs typeface="Helvetica"/>
-                </a:rPr>
-                <a:t>0.89</a:t>
-              </a:r>
-            </a:p>
-          </p:txBody>
-        </p:sp>
-        <p:sp>
-          <p:nvSpPr>
-            <p:cNvPr id="52" name="tx52"/>
-            <p:cNvSpPr/>
-            <p:nvPr/>
-          </p:nvSpPr>
-          <p:spPr>
-            <a:xfrm>
-              <a:off x="2673551" y="3608128"/>
-              <a:ext cx="77724" cy="100218"/>
-            </a:xfrm>
-            <a:prstGeom prst="rect">
-              <a:avLst/>
-            </a:prstGeom>
-            <a:noFill/>
-          </p:spPr>
-          <p:txBody>
-            <a:bodyPr lIns="0" rIns="0" tIns="0" bIns="0" anchorCtr="1" anchor="ctr" wrap="none"/>
-            <a:lstStyle/>
-            <a:p>
-              <a:pPr algn="l" marL="0" marR="0" indent="0">
-                <a:lnSpc>
-                  <a:spcPts val="1100"/>
-                </a:lnSpc>
-                <a:spcBef>
-                  <a:spcPts val="0"/>
-                </a:spcBef>
-                <a:spcAft>
-                  <a:spcPts val="0"/>
-                </a:spcAft>
-              </a:pPr>
-              <a:r>
-                <a:rPr sz="1100">
-                  <a:solidFill>
-                    <a:srgbClr val="000000">
-                      <a:alpha val="100000"/>
-                    </a:srgbClr>
-                  </a:solidFill>
-                  <a:latin typeface="Helvetica"/>
-                  <a:cs typeface="Helvetica"/>
-                </a:rPr>
-                <a:t>0</a:t>
-              </a:r>
-            </a:p>
-          </p:txBody>
-        </p:sp>
-        <p:sp>
-          <p:nvSpPr>
-            <p:cNvPr id="53" name="tx53"/>
-            <p:cNvSpPr/>
-            <p:nvPr/>
-          </p:nvSpPr>
-          <p:spPr>
-            <a:xfrm>
-              <a:off x="2673551" y="2959789"/>
-              <a:ext cx="77724" cy="100218"/>
-            </a:xfrm>
-            <a:prstGeom prst="rect">
-              <a:avLst/>
-            </a:prstGeom>
-            <a:noFill/>
-          </p:spPr>
-          <p:txBody>
-            <a:bodyPr lIns="0" rIns="0" tIns="0" bIns="0" anchorCtr="1" anchor="ctr" wrap="none"/>
-            <a:lstStyle/>
-            <a:p>
-              <a:pPr algn="l" marL="0" marR="0" indent="0">
-                <a:lnSpc>
-                  <a:spcPts val="1100"/>
-                </a:lnSpc>
-                <a:spcBef>
-                  <a:spcPts val="0"/>
-                </a:spcBef>
-                <a:spcAft>
-                  <a:spcPts val="0"/>
-                </a:spcAft>
-              </a:pPr>
-              <a:r>
-                <a:rPr sz="1100">
-                  <a:solidFill>
-                    <a:srgbClr val="000000">
-                      <a:alpha val="100000"/>
-                    </a:srgbClr>
-                  </a:solidFill>
-                  <a:latin typeface="Helvetica"/>
-                  <a:cs typeface="Helvetica"/>
-                </a:rPr>
-                <a:t>0</a:t>
-              </a:r>
-            </a:p>
-          </p:txBody>
-        </p:sp>
-        <p:sp>
-          <p:nvSpPr>
-            <p:cNvPr id="54" name="tx54"/>
-            <p:cNvSpPr/>
-            <p:nvPr/>
-          </p:nvSpPr>
-          <p:spPr>
-            <a:xfrm>
-              <a:off x="3224781" y="4256468"/>
-              <a:ext cx="271942" cy="100218"/>
-            </a:xfrm>
-            <a:prstGeom prst="rect">
-              <a:avLst/>
-            </a:prstGeom>
-            <a:noFill/>
-          </p:spPr>
-          <p:txBody>
-            <a:bodyPr lIns="0" rIns="0" tIns="0" bIns="0" anchorCtr="1" anchor="ctr" wrap="none"/>
-            <a:lstStyle/>
-            <a:p>
-              <a:pPr algn="l" marL="0" marR="0" indent="0">
-                <a:lnSpc>
-                  <a:spcPts val="1100"/>
-                </a:lnSpc>
-                <a:spcBef>
-                  <a:spcPts val="0"/>
-                </a:spcBef>
-                <a:spcAft>
-                  <a:spcPts val="0"/>
-                </a:spcAft>
-              </a:pPr>
-              <a:r>
-                <a:rPr sz="1100">
-                  <a:solidFill>
-                    <a:srgbClr val="000000">
-                      <a:alpha val="100000"/>
-                    </a:srgbClr>
-                  </a:solidFill>
-                  <a:latin typeface="Helvetica"/>
-                  <a:cs typeface="Helvetica"/>
-                </a:rPr>
-                <a:t>0.15</a:t>
-              </a:r>
-            </a:p>
-          </p:txBody>
-        </p:sp>
-        <p:sp>
-          <p:nvSpPr>
-            <p:cNvPr id="55" name="tx55"/>
-            <p:cNvSpPr/>
-            <p:nvPr/>
-          </p:nvSpPr>
-          <p:spPr>
-            <a:xfrm>
-              <a:off x="3224781" y="3608128"/>
-              <a:ext cx="271942" cy="100218"/>
-            </a:xfrm>
-            <a:prstGeom prst="rect">
-              <a:avLst/>
-            </a:prstGeom>
-            <a:noFill/>
-          </p:spPr>
-          <p:txBody>
-            <a:bodyPr lIns="0" rIns="0" tIns="0" bIns="0" anchorCtr="1" anchor="ctr" wrap="none"/>
-            <a:lstStyle/>
-            <a:p>
-              <a:pPr algn="l" marL="0" marR="0" indent="0">
-                <a:lnSpc>
-                  <a:spcPts val="1100"/>
-                </a:lnSpc>
-                <a:spcBef>
-                  <a:spcPts val="0"/>
-                </a:spcBef>
-                <a:spcAft>
-                  <a:spcPts val="0"/>
-                </a:spcAft>
-              </a:pPr>
-              <a:r>
-                <a:rPr sz="1100">
-                  <a:solidFill>
-                    <a:srgbClr val="000000">
-                      <a:alpha val="100000"/>
-                    </a:srgbClr>
-                  </a:solidFill>
-                  <a:latin typeface="Helvetica"/>
-                  <a:cs typeface="Helvetica"/>
-                </a:rPr>
-                <a:t>0.06</a:t>
-              </a:r>
-            </a:p>
-          </p:txBody>
-        </p:sp>
-        <p:sp>
-          <p:nvSpPr>
-            <p:cNvPr id="56" name="tx56"/>
-            <p:cNvSpPr/>
-            <p:nvPr/>
-          </p:nvSpPr>
-          <p:spPr>
-            <a:xfrm>
-              <a:off x="3321890" y="2959789"/>
-              <a:ext cx="77724" cy="100218"/>
-            </a:xfrm>
-            <a:prstGeom prst="rect">
-              <a:avLst/>
-            </a:prstGeom>
-            <a:noFill/>
-          </p:spPr>
-          <p:txBody>
-            <a:bodyPr lIns="0" rIns="0" tIns="0" bIns="0" anchorCtr="1" anchor="ctr" wrap="none"/>
-            <a:lstStyle/>
-            <a:p>
-              <a:pPr algn="l" marL="0" marR="0" indent="0">
-                <a:lnSpc>
-                  <a:spcPts val="1100"/>
-                </a:lnSpc>
-                <a:spcBef>
-                  <a:spcPts val="0"/>
-                </a:spcBef>
-                <a:spcAft>
-                  <a:spcPts val="0"/>
-                </a:spcAft>
-              </a:pPr>
-              <a:r>
-                <a:rPr sz="1100">
-                  <a:solidFill>
-                    <a:srgbClr val="000000">
-                      <a:alpha val="100000"/>
-                    </a:srgbClr>
-                  </a:solidFill>
-                  <a:latin typeface="Helvetica"/>
-                  <a:cs typeface="Helvetica"/>
-                </a:rPr>
-                <a:t>0</a:t>
-              </a:r>
-            </a:p>
-          </p:txBody>
-        </p:sp>
-        <p:sp>
-          <p:nvSpPr>
-            <p:cNvPr id="57" name="tx57"/>
-            <p:cNvSpPr/>
-            <p:nvPr/>
-          </p:nvSpPr>
-          <p:spPr>
-            <a:xfrm>
-              <a:off x="5169801" y="4256468"/>
-              <a:ext cx="271942" cy="100218"/>
-            </a:xfrm>
-            <a:prstGeom prst="rect">
-              <a:avLst/>
-            </a:prstGeom>
-            <a:noFill/>
-          </p:spPr>
-          <p:txBody>
-            <a:bodyPr lIns="0" rIns="0" tIns="0" bIns="0" anchorCtr="1" anchor="ctr" wrap="none"/>
-            <a:lstStyle/>
-            <a:p>
-              <a:pPr algn="l" marL="0" marR="0" indent="0">
-                <a:lnSpc>
-                  <a:spcPts val="1100"/>
-                </a:lnSpc>
-                <a:spcBef>
-                  <a:spcPts val="0"/>
-                </a:spcBef>
-                <a:spcAft>
-                  <a:spcPts val="0"/>
-                </a:spcAft>
-              </a:pPr>
-              <a:r>
-                <a:rPr sz="1100">
-                  <a:solidFill>
-                    <a:srgbClr val="FFFFFF">
-                      <a:alpha val="100000"/>
-                    </a:srgbClr>
-                  </a:solidFill>
-                  <a:latin typeface="Helvetica"/>
-                  <a:cs typeface="Helvetica"/>
-                </a:rPr>
-                <a:t>0.94</a:t>
-              </a:r>
-            </a:p>
-          </p:txBody>
-        </p:sp>
-        <p:sp>
-          <p:nvSpPr>
-            <p:cNvPr id="58" name="tx58"/>
-            <p:cNvSpPr/>
-            <p:nvPr/>
-          </p:nvSpPr>
-          <p:spPr>
-            <a:xfrm>
-              <a:off x="5169801" y="3608128"/>
-              <a:ext cx="271942" cy="100218"/>
-            </a:xfrm>
-            <a:prstGeom prst="rect">
-              <a:avLst/>
-            </a:prstGeom>
-            <a:noFill/>
-          </p:spPr>
-          <p:txBody>
-            <a:bodyPr lIns="0" rIns="0" tIns="0" bIns="0" anchorCtr="1" anchor="ctr" wrap="none"/>
-            <a:lstStyle/>
-            <a:p>
-              <a:pPr algn="l" marL="0" marR="0" indent="0">
-                <a:lnSpc>
-                  <a:spcPts val="1100"/>
-                </a:lnSpc>
-                <a:spcBef>
-                  <a:spcPts val="0"/>
-                </a:spcBef>
-                <a:spcAft>
-                  <a:spcPts val="0"/>
-                </a:spcAft>
-              </a:pPr>
-              <a:r>
-                <a:rPr sz="1100">
-                  <a:solidFill>
-                    <a:srgbClr val="000000">
-                      <a:alpha val="100000"/>
-                    </a:srgbClr>
-                  </a:solidFill>
-                  <a:latin typeface="Helvetica"/>
-                  <a:cs typeface="Helvetica"/>
-                </a:rPr>
-                <a:t>0.33</a:t>
-              </a:r>
-            </a:p>
-          </p:txBody>
-        </p:sp>
-        <p:sp>
-          <p:nvSpPr>
-            <p:cNvPr id="59" name="tx59"/>
-            <p:cNvSpPr/>
-            <p:nvPr/>
-          </p:nvSpPr>
-          <p:spPr>
-            <a:xfrm>
-              <a:off x="5266910" y="2959789"/>
-              <a:ext cx="77724" cy="100218"/>
-            </a:xfrm>
-            <a:prstGeom prst="rect">
-              <a:avLst/>
-            </a:prstGeom>
-            <a:noFill/>
-          </p:spPr>
-          <p:txBody>
-            <a:bodyPr lIns="0" rIns="0" tIns="0" bIns="0" anchorCtr="1" anchor="ctr" wrap="none"/>
-            <a:lstStyle/>
-            <a:p>
-              <a:pPr algn="l" marL="0" marR="0" indent="0">
-                <a:lnSpc>
-                  <a:spcPts val="1100"/>
-                </a:lnSpc>
-                <a:spcBef>
-                  <a:spcPts val="0"/>
-                </a:spcBef>
-                <a:spcAft>
-                  <a:spcPts val="0"/>
-                </a:spcAft>
-              </a:pPr>
-              <a:r>
-                <a:rPr sz="1100">
-                  <a:solidFill>
-                    <a:srgbClr val="000000">
-                      <a:alpha val="100000"/>
-                    </a:srgbClr>
-                  </a:solidFill>
-                  <a:latin typeface="Helvetica"/>
-                  <a:cs typeface="Helvetica"/>
-                </a:rPr>
-                <a:t>0</a:t>
-              </a:r>
-            </a:p>
-          </p:txBody>
-        </p:sp>
-        <p:sp>
-          <p:nvSpPr>
-            <p:cNvPr id="60" name="tx60"/>
-            <p:cNvSpPr/>
-            <p:nvPr/>
-          </p:nvSpPr>
-          <p:spPr>
-            <a:xfrm>
-              <a:off x="5915250" y="4256468"/>
-              <a:ext cx="77724" cy="100218"/>
-            </a:xfrm>
-            <a:prstGeom prst="rect">
-              <a:avLst/>
-            </a:prstGeom>
-            <a:noFill/>
-          </p:spPr>
-          <p:txBody>
-            <a:bodyPr lIns="0" rIns="0" tIns="0" bIns="0" anchorCtr="1" anchor="ctr" wrap="none"/>
-            <a:lstStyle/>
-            <a:p>
-              <a:pPr algn="l" marL="0" marR="0" indent="0">
-                <a:lnSpc>
-                  <a:spcPts val="1100"/>
-                </a:lnSpc>
-                <a:spcBef>
-                  <a:spcPts val="0"/>
-                </a:spcBef>
-                <a:spcAft>
-                  <a:spcPts val="0"/>
-                </a:spcAft>
-              </a:pPr>
-              <a:r>
-                <a:rPr sz="1100">
-                  <a:solidFill>
-                    <a:srgbClr val="000000">
-                      <a:alpha val="100000"/>
-                    </a:srgbClr>
-                  </a:solidFill>
-                  <a:latin typeface="Helvetica"/>
-                  <a:cs typeface="Helvetica"/>
-                </a:rPr>
-                <a:t>0</a:t>
-              </a:r>
-            </a:p>
-          </p:txBody>
-        </p:sp>
-        <p:sp>
-          <p:nvSpPr>
-            <p:cNvPr id="61" name="tx61"/>
-            <p:cNvSpPr/>
-            <p:nvPr/>
-          </p:nvSpPr>
-          <p:spPr>
-            <a:xfrm>
-              <a:off x="5818141" y="3608128"/>
-              <a:ext cx="271942" cy="100218"/>
-            </a:xfrm>
-            <a:prstGeom prst="rect">
-              <a:avLst/>
-            </a:prstGeom>
-            <a:noFill/>
-          </p:spPr>
-          <p:txBody>
-            <a:bodyPr lIns="0" rIns="0" tIns="0" bIns="0" anchorCtr="1" anchor="ctr" wrap="none"/>
-            <a:lstStyle/>
-            <a:p>
-              <a:pPr algn="l" marL="0" marR="0" indent="0">
-                <a:lnSpc>
-                  <a:spcPts val="1100"/>
-                </a:lnSpc>
-                <a:spcBef>
-                  <a:spcPts val="0"/>
-                </a:spcBef>
-                <a:spcAft>
-                  <a:spcPts val="0"/>
-                </a:spcAft>
-              </a:pPr>
-              <a:r>
-                <a:rPr sz="1100">
-                  <a:solidFill>
-                    <a:srgbClr val="000000">
-                      <a:alpha val="100000"/>
-                    </a:srgbClr>
-                  </a:solidFill>
-                  <a:latin typeface="Helvetica"/>
-                  <a:cs typeface="Helvetica"/>
-                </a:rPr>
-                <a:t>0.14</a:t>
-              </a:r>
-            </a:p>
-          </p:txBody>
-        </p:sp>
-        <p:sp>
-          <p:nvSpPr>
-            <p:cNvPr id="62" name="tx62"/>
-            <p:cNvSpPr/>
-            <p:nvPr/>
-          </p:nvSpPr>
-          <p:spPr>
-            <a:xfrm>
-              <a:off x="5915250" y="2959789"/>
-              <a:ext cx="77724" cy="100218"/>
-            </a:xfrm>
-            <a:prstGeom prst="rect">
-              <a:avLst/>
-            </a:prstGeom>
-            <a:noFill/>
-          </p:spPr>
-          <p:txBody>
-            <a:bodyPr lIns="0" rIns="0" tIns="0" bIns="0" anchorCtr="1" anchor="ctr" wrap="none"/>
-            <a:lstStyle/>
-            <a:p>
-              <a:pPr algn="l" marL="0" marR="0" indent="0">
-                <a:lnSpc>
-                  <a:spcPts val="1100"/>
-                </a:lnSpc>
-                <a:spcBef>
-                  <a:spcPts val="0"/>
-                </a:spcBef>
-                <a:spcAft>
-                  <a:spcPts val="0"/>
-                </a:spcAft>
-              </a:pPr>
-              <a:r>
-                <a:rPr sz="1100">
-                  <a:solidFill>
-                    <a:srgbClr val="000000">
-                      <a:alpha val="100000"/>
-                    </a:srgbClr>
-                  </a:solidFill>
-                  <a:latin typeface="Helvetica"/>
-                  <a:cs typeface="Helvetica"/>
-                </a:rPr>
-                <a:t>0</a:t>
-              </a:r>
-            </a:p>
-          </p:txBody>
-        </p:sp>
-        <p:sp>
-          <p:nvSpPr>
-            <p:cNvPr id="63" name="tx63"/>
-            <p:cNvSpPr/>
-            <p:nvPr/>
-          </p:nvSpPr>
-          <p:spPr>
-            <a:xfrm>
-              <a:off x="7114820" y="4256468"/>
-              <a:ext cx="271942" cy="100218"/>
-            </a:xfrm>
-            <a:prstGeom prst="rect">
-              <a:avLst/>
-            </a:prstGeom>
-            <a:noFill/>
-          </p:spPr>
-          <p:txBody>
-            <a:bodyPr lIns="0" rIns="0" tIns="0" bIns="0" anchorCtr="1" anchor="ctr" wrap="none"/>
-            <a:lstStyle/>
-            <a:p>
-              <a:pPr algn="l" marL="0" marR="0" indent="0">
-                <a:lnSpc>
-                  <a:spcPts val="1100"/>
-                </a:lnSpc>
-                <a:spcBef>
-                  <a:spcPts val="0"/>
-                </a:spcBef>
-                <a:spcAft>
-                  <a:spcPts val="0"/>
-                </a:spcAft>
-              </a:pPr>
-              <a:r>
-                <a:rPr sz="1100">
-                  <a:solidFill>
-                    <a:srgbClr val="FFFFFF">
-                      <a:alpha val="100000"/>
-                    </a:srgbClr>
-                  </a:solidFill>
-                  <a:latin typeface="Helvetica"/>
-                  <a:cs typeface="Helvetica"/>
-                </a:rPr>
-                <a:t>0.65</a:t>
-              </a:r>
-            </a:p>
-          </p:txBody>
-        </p:sp>
-        <p:sp>
-          <p:nvSpPr>
-            <p:cNvPr id="64" name="tx64"/>
-            <p:cNvSpPr/>
-            <p:nvPr/>
-          </p:nvSpPr>
-          <p:spPr>
-            <a:xfrm>
-              <a:off x="7114820" y="3608128"/>
+              <a:off x="7106774" y="3277253"/>
               <a:ext cx="271942" cy="100218"/>
             </a:xfrm>
             <a:prstGeom prst="rect">
@@ -7883,59 +7119,13 @@
         </p:sp>
         <p:sp>
           <p:nvSpPr>
-            <p:cNvPr id="65" name="tx65"/>
-            <p:cNvSpPr/>
-            <p:nvPr/>
-          </p:nvSpPr>
-          <p:spPr>
-            <a:xfrm>
-              <a:off x="7114820" y="2959789"/>
-              <a:ext cx="271942" cy="100218"/>
-            </a:xfrm>
-            <a:prstGeom prst="rect">
-              <a:avLst/>
-            </a:prstGeom>
-            <a:noFill/>
-          </p:spPr>
-          <p:txBody>
-            <a:bodyPr lIns="0" rIns="0" tIns="0" bIns="0" anchorCtr="1" anchor="ctr" wrap="none"/>
-            <a:lstStyle/>
-            <a:p>
-              <a:pPr algn="l" marL="0" marR="0" indent="0">
-                <a:lnSpc>
-                  <a:spcPts val="1100"/>
-                </a:lnSpc>
-                <a:spcBef>
-                  <a:spcPts val="0"/>
-                </a:spcBef>
-                <a:spcAft>
-                  <a:spcPts val="0"/>
-                </a:spcAft>
-              </a:pPr>
-              <a:r>
-                <a:rPr sz="1100">
-                  <a:solidFill>
-                    <a:srgbClr val="000000">
-                      <a:alpha val="100000"/>
-                    </a:srgbClr>
-                  </a:solidFill>
-                  <a:latin typeface="Helvetica"/>
-                  <a:cs typeface="Helvetica"/>
-                </a:rPr>
-                <a:t>0.49</a:t>
-              </a:r>
-            </a:p>
-          </p:txBody>
-        </p:sp>
-        <p:sp>
-          <p:nvSpPr>
-            <p:cNvPr id="66" name="tx66"/>
-            <p:cNvSpPr/>
-            <p:nvPr/>
-          </p:nvSpPr>
-          <p:spPr>
-            <a:xfrm>
-              <a:off x="663583" y="4266527"/>
+            <p:cNvPr id="46" name="tx46"/>
+            <p:cNvSpPr/>
+            <p:nvPr/>
+          </p:nvSpPr>
+          <p:spPr>
+            <a:xfrm>
+              <a:off x="526789" y="3949062"/>
               <a:ext cx="335310" cy="80101"/>
             </a:xfrm>
             <a:prstGeom prst="rect">
@@ -7975,13 +7165,13 @@
         </p:sp>
         <p:sp>
           <p:nvSpPr>
-            <p:cNvPr id="67" name="tx67"/>
-            <p:cNvSpPr/>
-            <p:nvPr/>
-          </p:nvSpPr>
-          <p:spPr>
-            <a:xfrm>
-              <a:off x="756760" y="3618187"/>
+            <p:cNvPr id="47" name="tx47"/>
+            <p:cNvSpPr/>
+            <p:nvPr/>
+          </p:nvSpPr>
+          <p:spPr>
+            <a:xfrm>
+              <a:off x="619966" y="3287311"/>
               <a:ext cx="242133" cy="80101"/>
             </a:xfrm>
             <a:prstGeom prst="rect">
@@ -8021,59 +7211,13 @@
         </p:sp>
         <p:sp>
           <p:nvSpPr>
-            <p:cNvPr id="68" name="tx68"/>
-            <p:cNvSpPr/>
-            <p:nvPr/>
-          </p:nvSpPr>
-          <p:spPr>
-            <a:xfrm>
-              <a:off x="526789" y="2969847"/>
-              <a:ext cx="472104" cy="80101"/>
-            </a:xfrm>
-            <a:prstGeom prst="rect">
-              <a:avLst/>
-            </a:prstGeom>
-            <a:noFill/>
-          </p:spPr>
-          <p:txBody>
-            <a:bodyPr lIns="0" rIns="0" tIns="0" bIns="0" anchorCtr="1" anchor="ctr" wrap="none"/>
-            <a:lstStyle/>
-            <a:p>
-              <a:pPr algn="l" marL="0" marR="0" indent="0">
-                <a:lnSpc>
-                  <a:spcPts val="880"/>
-                </a:lnSpc>
-                <a:spcBef>
-                  <a:spcPts val="0"/>
-                </a:spcBef>
-                <a:spcAft>
-                  <a:spcPts val="0"/>
-                </a:spcAft>
-              </a:pPr>
-              <a:r>
-                <a:rPr sz="880">
-                  <a:solidFill>
-                    <a:srgbClr val="000000">
-                      <a:alpha val="100000"/>
-                    </a:srgbClr>
-                  </a:solidFill>
-                  <a:latin typeface="Helvetica"/>
-                  <a:cs typeface="Helvetica"/>
-                </a:rPr>
-                <a:t>Pea Crab</a:t>
-              </a:r>
-            </a:p>
-          </p:txBody>
-        </p:sp>
-        <p:sp>
-          <p:nvSpPr>
-            <p:cNvPr id="69" name="tx69"/>
+            <p:cNvPr id="48" name="tx48"/>
             <p:cNvSpPr/>
             <p:nvPr/>
           </p:nvSpPr>
           <p:spPr>
             <a:xfrm rot="-2700000">
-              <a:off x="1147389" y="4834569"/>
+              <a:off x="1018641" y="4525151"/>
               <a:ext cx="347563" cy="80101"/>
             </a:xfrm>
             <a:prstGeom prst="rect">
@@ -8113,13 +7257,13 @@
         </p:sp>
         <p:sp>
           <p:nvSpPr>
-            <p:cNvPr id="70" name="tx70"/>
+            <p:cNvPr id="49" name="tx49"/>
             <p:cNvSpPr/>
             <p:nvPr/>
           </p:nvSpPr>
           <p:spPr>
             <a:xfrm rot="-2700000">
-              <a:off x="1800880" y="4832435"/>
+              <a:off x="1685544" y="4523017"/>
               <a:ext cx="341528" cy="80101"/>
             </a:xfrm>
             <a:prstGeom prst="rect">
@@ -8159,13 +7303,13 @@
         </p:sp>
         <p:sp>
           <p:nvSpPr>
-            <p:cNvPr id="71" name="tx71"/>
+            <p:cNvPr id="50" name="tx50"/>
             <p:cNvSpPr/>
             <p:nvPr/>
           </p:nvSpPr>
           <p:spPr>
             <a:xfrm rot="-2700000">
-              <a:off x="2454605" y="4830204"/>
+              <a:off x="2352680" y="4520787"/>
               <a:ext cx="335219" cy="80101"/>
             </a:xfrm>
             <a:prstGeom prst="rect">
@@ -8205,13 +7349,13 @@
         </p:sp>
         <p:sp>
           <p:nvSpPr>
-            <p:cNvPr id="72" name="tx72"/>
+            <p:cNvPr id="51" name="tx51"/>
             <p:cNvSpPr/>
             <p:nvPr/>
           </p:nvSpPr>
           <p:spPr>
             <a:xfrm rot="-2700000">
-              <a:off x="3087023" y="4836799"/>
+              <a:off x="2998509" y="4527382"/>
               <a:ext cx="353872" cy="80101"/>
             </a:xfrm>
             <a:prstGeom prst="rect">
@@ -8251,13 +7395,13 @@
         </p:sp>
         <p:sp>
           <p:nvSpPr>
-            <p:cNvPr id="73" name="tx73"/>
+            <p:cNvPr id="52" name="tx52"/>
             <p:cNvSpPr/>
             <p:nvPr/>
           </p:nvSpPr>
           <p:spPr>
             <a:xfrm rot="-2700000">
-              <a:off x="3645060" y="4874204"/>
+              <a:off x="3569958" y="4564786"/>
               <a:ext cx="459668" cy="80101"/>
             </a:xfrm>
             <a:prstGeom prst="rect">
@@ -8297,13 +7441,13 @@
         </p:sp>
         <p:sp>
           <p:nvSpPr>
-            <p:cNvPr id="74" name="tx74"/>
+            <p:cNvPr id="53" name="tx53"/>
             <p:cNvSpPr/>
             <p:nvPr/>
           </p:nvSpPr>
           <p:spPr>
             <a:xfrm rot="-2700000">
-              <a:off x="4277634" y="4880734"/>
+              <a:off x="4215943" y="4571317"/>
               <a:ext cx="478139" cy="80101"/>
             </a:xfrm>
             <a:prstGeom prst="rect">
@@ -8343,13 +7487,13 @@
         </p:sp>
         <p:sp>
           <p:nvSpPr>
-            <p:cNvPr id="75" name="tx75"/>
+            <p:cNvPr id="54" name="tx54"/>
             <p:cNvSpPr/>
             <p:nvPr/>
           </p:nvSpPr>
           <p:spPr>
             <a:xfrm rot="-2700000">
-              <a:off x="5021584" y="4841131"/>
+              <a:off x="4973304" y="4531714"/>
               <a:ext cx="366125" cy="80101"/>
             </a:xfrm>
             <a:prstGeom prst="rect">
@@ -8389,13 +7533,13 @@
         </p:sp>
         <p:sp>
           <p:nvSpPr>
-            <p:cNvPr id="76" name="tx76"/>
+            <p:cNvPr id="55" name="tx55"/>
             <p:cNvSpPr/>
             <p:nvPr/>
           </p:nvSpPr>
           <p:spPr>
             <a:xfrm rot="-2700000">
-              <a:off x="5664539" y="4843362"/>
+              <a:off x="5629670" y="4533944"/>
               <a:ext cx="372435" cy="80101"/>
             </a:xfrm>
             <a:prstGeom prst="rect">
@@ -8435,13 +7579,13 @@
         </p:sp>
         <p:sp>
           <p:nvSpPr>
-            <p:cNvPr id="77" name="tx77"/>
+            <p:cNvPr id="56" name="tx56"/>
             <p:cNvSpPr/>
             <p:nvPr/>
           </p:nvSpPr>
           <p:spPr>
             <a:xfrm rot="-2700000">
-              <a:off x="6227883" y="4878568"/>
+              <a:off x="6206425" y="4569151"/>
               <a:ext cx="472013" cy="80101"/>
             </a:xfrm>
             <a:prstGeom prst="rect">
@@ -8481,13 +7625,13 @@
         </p:sp>
         <p:sp>
           <p:nvSpPr>
-            <p:cNvPr id="78" name="tx78"/>
+            <p:cNvPr id="57" name="tx57"/>
             <p:cNvSpPr/>
             <p:nvPr/>
           </p:nvSpPr>
           <p:spPr>
             <a:xfrm rot="-2700000">
-              <a:off x="6833999" y="4896058"/>
+              <a:off x="6825952" y="4586641"/>
               <a:ext cx="521482" cy="80101"/>
             </a:xfrm>
             <a:prstGeom prst="rect">
@@ -8527,13 +7671,13 @@
         </p:sp>
         <p:sp>
           <p:nvSpPr>
-            <p:cNvPr id="79" name="tx79"/>
-            <p:cNvSpPr/>
-            <p:nvPr/>
-          </p:nvSpPr>
-          <p:spPr>
-            <a:xfrm>
-              <a:off x="4212927" y="5201118"/>
+            <p:cNvPr id="58" name="tx58"/>
+            <p:cNvSpPr/>
+            <p:nvPr/>
+          </p:nvSpPr>
+          <p:spPr>
+            <a:xfrm>
+              <a:off x="4144530" y="4891700"/>
               <a:ext cx="240670" cy="100218"/>
             </a:xfrm>
             <a:prstGeom prst="rect">
@@ -8573,7 +7717,7 @@
         </p:sp>
         <p:sp>
           <p:nvSpPr>
-            <p:cNvPr id="80" name="rc80"/>
+            <p:cNvPr id="59" name="rc59"/>
             <p:cNvSpPr/>
             <p:nvPr/>
           </p:nvSpPr>
@@ -8599,7 +7743,7 @@
         </p:sp>
         <p:sp>
           <p:nvSpPr>
-            <p:cNvPr id="81" name="tx81"/>
+            <p:cNvPr id="60" name="tx60"/>
             <p:cNvSpPr/>
             <p:nvPr/>
           </p:nvSpPr>
@@ -8645,7 +7789,7 @@
         </p:sp>
         <p:pic>
           <p:nvPicPr>
-            <p:cNvPr id="82" name="pic82"/>
+            <p:cNvPr id="61" name="pic61"/>
             <p:cNvPicPr/>
             <p:nvPr/>
           </p:nvPicPr>
@@ -8667,7 +7811,7 @@
         </p:pic>
         <p:sp>
           <p:nvSpPr>
-            <p:cNvPr id="83" name="pl83"/>
+            <p:cNvPr id="62" name="pl62"/>
             <p:cNvSpPr/>
             <p:nvPr/>
           </p:nvSpPr>
@@ -8707,7 +7851,7 @@
         </p:sp>
         <p:sp>
           <p:nvSpPr>
-            <p:cNvPr id="84" name="pl84"/>
+            <p:cNvPr id="63" name="pl63"/>
             <p:cNvSpPr/>
             <p:nvPr/>
           </p:nvSpPr>
@@ -8747,7 +7891,7 @@
         </p:sp>
         <p:sp>
           <p:nvSpPr>
-            <p:cNvPr id="85" name="pl85"/>
+            <p:cNvPr id="64" name="pl64"/>
             <p:cNvSpPr/>
             <p:nvPr/>
           </p:nvSpPr>
@@ -8787,7 +7931,7 @@
         </p:sp>
         <p:sp>
           <p:nvSpPr>
-            <p:cNvPr id="86" name="pl86"/>
+            <p:cNvPr id="65" name="pl65"/>
             <p:cNvSpPr/>
             <p:nvPr/>
           </p:nvSpPr>
@@ -8827,7 +7971,7 @@
         </p:sp>
         <p:sp>
           <p:nvSpPr>
-            <p:cNvPr id="87" name="pl87"/>
+            <p:cNvPr id="66" name="pl66"/>
             <p:cNvSpPr/>
             <p:nvPr/>
           </p:nvSpPr>
@@ -8867,7 +8011,7 @@
         </p:sp>
         <p:sp>
           <p:nvSpPr>
-            <p:cNvPr id="88" name="pl88"/>
+            <p:cNvPr id="67" name="pl67"/>
             <p:cNvSpPr/>
             <p:nvPr/>
           </p:nvSpPr>
@@ -8907,7 +8051,7 @@
         </p:sp>
         <p:sp>
           <p:nvSpPr>
-            <p:cNvPr id="89" name="pl89"/>
+            <p:cNvPr id="68" name="pl68"/>
             <p:cNvSpPr/>
             <p:nvPr/>
           </p:nvSpPr>
@@ -8947,7 +8091,7 @@
         </p:sp>
         <p:sp>
           <p:nvSpPr>
-            <p:cNvPr id="90" name="pl90"/>
+            <p:cNvPr id="69" name="pl69"/>
             <p:cNvSpPr/>
             <p:nvPr/>
           </p:nvSpPr>
@@ -8987,7 +8131,7 @@
         </p:sp>
         <p:sp>
           <p:nvSpPr>
-            <p:cNvPr id="91" name="pl91"/>
+            <p:cNvPr id="70" name="pl70"/>
             <p:cNvSpPr/>
             <p:nvPr/>
           </p:nvSpPr>
@@ -9027,7 +8171,7 @@
         </p:sp>
         <p:sp>
           <p:nvSpPr>
-            <p:cNvPr id="92" name="pl92"/>
+            <p:cNvPr id="71" name="pl71"/>
             <p:cNvSpPr/>
             <p:nvPr/>
           </p:nvSpPr>
@@ -9067,7 +8211,7 @@
         </p:sp>
         <p:sp>
           <p:nvSpPr>
-            <p:cNvPr id="93" name="tx93"/>
+            <p:cNvPr id="72" name="tx72"/>
             <p:cNvSpPr/>
             <p:nvPr/>
           </p:nvSpPr>
@@ -9113,7 +8257,7 @@
         </p:sp>
         <p:sp>
           <p:nvSpPr>
-            <p:cNvPr id="94" name="tx94"/>
+            <p:cNvPr id="73" name="tx73"/>
             <p:cNvSpPr/>
             <p:nvPr/>
           </p:nvSpPr>
@@ -9159,7 +8303,7 @@
         </p:sp>
         <p:sp>
           <p:nvSpPr>
-            <p:cNvPr id="95" name="tx95"/>
+            <p:cNvPr id="74" name="tx74"/>
             <p:cNvSpPr/>
             <p:nvPr/>
           </p:nvSpPr>
@@ -9205,7 +8349,7 @@
         </p:sp>
         <p:sp>
           <p:nvSpPr>
-            <p:cNvPr id="96" name="tx96"/>
+            <p:cNvPr id="75" name="tx75"/>
             <p:cNvSpPr/>
             <p:nvPr/>
           </p:nvSpPr>
@@ -9251,7 +8395,7 @@
         </p:sp>
         <p:sp>
           <p:nvSpPr>
-            <p:cNvPr id="97" name="tx97"/>
+            <p:cNvPr id="76" name="tx76"/>
             <p:cNvSpPr/>
             <p:nvPr/>
           </p:nvSpPr>
@@ -9297,13 +8441,13 @@
         </p:sp>
         <p:sp>
           <p:nvSpPr>
-            <p:cNvPr id="98" name="tx98"/>
-            <p:cNvSpPr/>
-            <p:nvPr/>
-          </p:nvSpPr>
-          <p:spPr>
-            <a:xfrm>
-              <a:off x="1026729" y="2394119"/>
+            <p:cNvPr id="77" name="tx77"/>
+            <p:cNvSpPr/>
+            <p:nvPr/>
+          </p:nvSpPr>
+          <p:spPr>
+            <a:xfrm>
+              <a:off x="889935" y="2703537"/>
               <a:ext cx="1489923" cy="120152"/>
             </a:xfrm>
             <a:prstGeom prst="rect">
@@ -9492,7 +8636,7 @@
               <a:avLst/>
             </a:prstGeom>
             <a:solidFill>
-              <a:srgbClr val="3A74A1">
+              <a:srgbClr val="3B538E">
                 <a:alpha val="100000"/>
               </a:srgbClr>
             </a:solidFill>
@@ -9562,7 +8706,7 @@
               <a:avLst/>
             </a:prstGeom>
             <a:solidFill>
-              <a:srgbClr val="3B528D">
+              <a:srgbClr val="3B3969">
                 <a:alpha val="100000"/>
               </a:srgbClr>
             </a:solidFill>
@@ -9597,7 +8741,7 @@
               <a:avLst/>
             </a:prstGeom>
             <a:solidFill>
-              <a:srgbClr val="3B5590">
+              <a:srgbClr val="4BB0AB">
                 <a:alpha val="100000"/>
               </a:srgbClr>
             </a:solidFill>
@@ -9626,251 +8770,6 @@
           <p:spPr>
             <a:xfrm>
               <a:off x="3980114" y="4194917"/>
-              <a:ext cx="391006" cy="391006"/>
-            </a:xfrm>
-            <a:prstGeom prst="rect">
-              <a:avLst/>
-            </a:prstGeom>
-            <a:solidFill>
-              <a:srgbClr val="3B5590">
-                <a:alpha val="100000"/>
-              </a:srgbClr>
-            </a:solidFill>
-            <a:ln w="5420" cap="flat">
-              <a:solidFill>
-                <a:srgbClr val="000000">
-                  <a:alpha val="100000"/>
-                </a:srgbClr>
-              </a:solidFill>
-              <a:prstDash val="solid"/>
-              <a:miter/>
-            </a:ln>
-          </p:spPr>
-          <p:txBody>
-            <a:bodyPr/>
-            <a:lstStyle/>
-            <a:p/>
-          </p:txBody>
-        </p:sp>
-        <p:sp>
-          <p:nvSpPr>
-            <p:cNvPr id="11" name="rc11"/>
-            <p:cNvSpPr/>
-            <p:nvPr/>
-          </p:nvSpPr>
-          <p:spPr>
-            <a:xfrm>
-              <a:off x="3980114" y="4585923"/>
-              <a:ext cx="391006" cy="391006"/>
-            </a:xfrm>
-            <a:prstGeom prst="rect">
-              <a:avLst/>
-            </a:prstGeom>
-            <a:solidFill>
-              <a:srgbClr val="45A8AA">
-                <a:alpha val="100000"/>
-              </a:srgbClr>
-            </a:solidFill>
-            <a:ln w="5420" cap="flat">
-              <a:solidFill>
-                <a:srgbClr val="000000">
-                  <a:alpha val="100000"/>
-                </a:srgbClr>
-              </a:solidFill>
-              <a:prstDash val="solid"/>
-              <a:miter/>
-            </a:ln>
-          </p:spPr>
-          <p:txBody>
-            <a:bodyPr/>
-            <a:lstStyle/>
-            <a:p/>
-          </p:txBody>
-        </p:sp>
-        <p:sp>
-          <p:nvSpPr>
-            <p:cNvPr id="12" name="rc12"/>
-            <p:cNvSpPr/>
-            <p:nvPr/>
-          </p:nvSpPr>
-          <p:spPr>
-            <a:xfrm>
-              <a:off x="3980114" y="4976930"/>
-              <a:ext cx="391006" cy="391006"/>
-            </a:xfrm>
-            <a:prstGeom prst="rect">
-              <a:avLst/>
-            </a:prstGeom>
-            <a:solidFill>
-              <a:srgbClr val="3B72A1">
-                <a:alpha val="100000"/>
-              </a:srgbClr>
-            </a:solidFill>
-            <a:ln w="5420" cap="flat">
-              <a:solidFill>
-                <a:srgbClr val="000000">
-                  <a:alpha val="100000"/>
-                </a:srgbClr>
-              </a:solidFill>
-              <a:prstDash val="solid"/>
-              <a:miter/>
-            </a:ln>
-          </p:spPr>
-          <p:txBody>
-            <a:bodyPr/>
-            <a:lstStyle/>
-            <a:p/>
-          </p:txBody>
-        </p:sp>
-        <p:sp>
-          <p:nvSpPr>
-            <p:cNvPr id="13" name="rc13"/>
-            <p:cNvSpPr/>
-            <p:nvPr/>
-          </p:nvSpPr>
-          <p:spPr>
-            <a:xfrm>
-              <a:off x="3980114" y="3412904"/>
-              <a:ext cx="391006" cy="391006"/>
-            </a:xfrm>
-            <a:prstGeom prst="rect">
-              <a:avLst/>
-            </a:prstGeom>
-            <a:solidFill>
-              <a:srgbClr val="C8EEDA">
-                <a:alpha val="100000"/>
-              </a:srgbClr>
-            </a:solidFill>
-            <a:ln w="5420" cap="flat">
-              <a:solidFill>
-                <a:srgbClr val="000000">
-                  <a:alpha val="100000"/>
-                </a:srgbClr>
-              </a:solidFill>
-              <a:prstDash val="solid"/>
-              <a:miter/>
-            </a:ln>
-          </p:spPr>
-          <p:txBody>
-            <a:bodyPr/>
-            <a:lstStyle/>
-            <a:p/>
-          </p:txBody>
-        </p:sp>
-        <p:sp>
-          <p:nvSpPr>
-            <p:cNvPr id="14" name="rc14"/>
-            <p:cNvSpPr/>
-            <p:nvPr/>
-          </p:nvSpPr>
-          <p:spPr>
-            <a:xfrm>
-              <a:off x="4371120" y="4194917"/>
-              <a:ext cx="391006" cy="391006"/>
-            </a:xfrm>
-            <a:prstGeom prst="rect">
-              <a:avLst/>
-            </a:prstGeom>
-            <a:solidFill>
-              <a:srgbClr val="392E5A">
-                <a:alpha val="100000"/>
-              </a:srgbClr>
-            </a:solidFill>
-            <a:ln w="5420" cap="flat">
-              <a:solidFill>
-                <a:srgbClr val="000000">
-                  <a:alpha val="100000"/>
-                </a:srgbClr>
-              </a:solidFill>
-              <a:prstDash val="solid"/>
-              <a:miter/>
-            </a:ln>
-          </p:spPr>
-          <p:txBody>
-            <a:bodyPr/>
-            <a:lstStyle/>
-            <a:p/>
-          </p:txBody>
-        </p:sp>
-        <p:sp>
-          <p:nvSpPr>
-            <p:cNvPr id="15" name="rc15"/>
-            <p:cNvSpPr/>
-            <p:nvPr/>
-          </p:nvSpPr>
-          <p:spPr>
-            <a:xfrm>
-              <a:off x="4371120" y="3021897"/>
-              <a:ext cx="391006" cy="391006"/>
-            </a:xfrm>
-            <a:prstGeom prst="rect">
-              <a:avLst/>
-            </a:prstGeom>
-            <a:solidFill>
-              <a:srgbClr val="8FDBBF">
-                <a:alpha val="100000"/>
-              </a:srgbClr>
-            </a:solidFill>
-            <a:ln w="5420" cap="flat">
-              <a:solidFill>
-                <a:srgbClr val="000000">
-                  <a:alpha val="100000"/>
-                </a:srgbClr>
-              </a:solidFill>
-              <a:prstDash val="solid"/>
-              <a:miter/>
-            </a:ln>
-          </p:spPr>
-          <p:txBody>
-            <a:bodyPr/>
-            <a:lstStyle/>
-            <a:p/>
-          </p:txBody>
-        </p:sp>
-        <p:sp>
-          <p:nvSpPr>
-            <p:cNvPr id="16" name="rc16"/>
-            <p:cNvSpPr/>
-            <p:nvPr/>
-          </p:nvSpPr>
-          <p:spPr>
-            <a:xfrm>
-              <a:off x="4371120" y="3412904"/>
-              <a:ext cx="391006" cy="391006"/>
-            </a:xfrm>
-            <a:prstGeom prst="rect">
-              <a:avLst/>
-            </a:prstGeom>
-            <a:solidFill>
-              <a:srgbClr val="3C487E">
-                <a:alpha val="100000"/>
-              </a:srgbClr>
-            </a:solidFill>
-            <a:ln w="5420" cap="flat">
-              <a:solidFill>
-                <a:srgbClr val="000000">
-                  <a:alpha val="100000"/>
-                </a:srgbClr>
-              </a:solidFill>
-              <a:prstDash val="solid"/>
-              <a:miter/>
-            </a:ln>
-          </p:spPr>
-          <p:txBody>
-            <a:bodyPr/>
-            <a:lstStyle/>
-            <a:p/>
-          </p:txBody>
-        </p:sp>
-        <p:sp>
-          <p:nvSpPr>
-            <p:cNvPr id="17" name="rc17"/>
-            <p:cNvSpPr/>
-            <p:nvPr/>
-          </p:nvSpPr>
-          <p:spPr>
-            <a:xfrm>
-              <a:off x="4371120" y="4976930"/>
               <a:ext cx="391006" cy="391006"/>
             </a:xfrm>
             <a:prstGeom prst="rect">
@@ -9899,20 +8798,20 @@
         </p:sp>
         <p:sp>
           <p:nvSpPr>
-            <p:cNvPr id="18" name="rc18"/>
-            <p:cNvSpPr/>
-            <p:nvPr/>
-          </p:nvSpPr>
-          <p:spPr>
-            <a:xfrm>
-              <a:off x="4371120" y="3803910"/>
+            <p:cNvPr id="11" name="rc11"/>
+            <p:cNvSpPr/>
+            <p:nvPr/>
+          </p:nvSpPr>
+          <p:spPr>
+            <a:xfrm>
+              <a:off x="3980114" y="4585923"/>
               <a:ext cx="391006" cy="391006"/>
             </a:xfrm>
             <a:prstGeom prst="rect">
               <a:avLst/>
             </a:prstGeom>
             <a:solidFill>
-              <a:srgbClr val="3C4C84">
+              <a:srgbClr val="379AA9">
                 <a:alpha val="100000"/>
               </a:srgbClr>
             </a:solidFill>
@@ -9934,20 +8833,20 @@
         </p:sp>
         <p:sp>
           <p:nvSpPr>
-            <p:cNvPr id="19" name="rc19"/>
-            <p:cNvSpPr/>
-            <p:nvPr/>
-          </p:nvSpPr>
-          <p:spPr>
-            <a:xfrm>
-              <a:off x="4371120" y="4585923"/>
+            <p:cNvPr id="12" name="rc12"/>
+            <p:cNvSpPr/>
+            <p:nvPr/>
+          </p:nvSpPr>
+          <p:spPr>
+            <a:xfrm>
+              <a:off x="3980114" y="4976930"/>
               <a:ext cx="391006" cy="391006"/>
             </a:xfrm>
             <a:prstGeom prst="rect">
               <a:avLst/>
             </a:prstGeom>
             <a:solidFill>
-              <a:srgbClr val="3A3665">
+              <a:srgbClr val="3B5591">
                 <a:alpha val="100000"/>
               </a:srgbClr>
             </a:solidFill>
@@ -9969,20 +8868,20 @@
         </p:sp>
         <p:sp>
           <p:nvSpPr>
-            <p:cNvPr id="20" name="rc20"/>
-            <p:cNvSpPr/>
-            <p:nvPr/>
-          </p:nvSpPr>
-          <p:spPr>
-            <a:xfrm>
-              <a:off x="4371120" y="2239884"/>
+            <p:cNvPr id="13" name="rc13"/>
+            <p:cNvSpPr/>
+            <p:nvPr/>
+          </p:nvSpPr>
+          <p:spPr>
+            <a:xfrm>
+              <a:off x="3980114" y="3412904"/>
               <a:ext cx="391006" cy="391006"/>
             </a:xfrm>
             <a:prstGeom prst="rect">
               <a:avLst/>
             </a:prstGeom>
             <a:solidFill>
-              <a:srgbClr val="382A55">
+              <a:srgbClr val="C5EDD8">
                 <a:alpha val="100000"/>
               </a:srgbClr>
             </a:solidFill>
@@ -10004,6 +8903,251 @@
         </p:sp>
         <p:sp>
           <p:nvSpPr>
+            <p:cNvPr id="14" name="rc14"/>
+            <p:cNvSpPr/>
+            <p:nvPr/>
+          </p:nvSpPr>
+          <p:spPr>
+            <a:xfrm>
+              <a:off x="4371120" y="4194917"/>
+              <a:ext cx="391006" cy="391006"/>
+            </a:xfrm>
+            <a:prstGeom prst="rect">
+              <a:avLst/>
+            </a:prstGeom>
+            <a:solidFill>
+              <a:srgbClr val="3A5793">
+                <a:alpha val="100000"/>
+              </a:srgbClr>
+            </a:solidFill>
+            <a:ln w="5420" cap="flat">
+              <a:solidFill>
+                <a:srgbClr val="000000">
+                  <a:alpha val="100000"/>
+                </a:srgbClr>
+              </a:solidFill>
+              <a:prstDash val="solid"/>
+              <a:miter/>
+            </a:ln>
+          </p:spPr>
+          <p:txBody>
+            <a:bodyPr/>
+            <a:lstStyle/>
+            <a:p/>
+          </p:txBody>
+        </p:sp>
+        <p:sp>
+          <p:nvSpPr>
+            <p:cNvPr id="15" name="rc15"/>
+            <p:cNvSpPr/>
+            <p:nvPr/>
+          </p:nvSpPr>
+          <p:spPr>
+            <a:xfrm>
+              <a:off x="4371120" y="3021897"/>
+              <a:ext cx="391006" cy="391006"/>
+            </a:xfrm>
+            <a:prstGeom prst="rect">
+              <a:avLst/>
+            </a:prstGeom>
+            <a:solidFill>
+              <a:srgbClr val="80D7B8">
+                <a:alpha val="100000"/>
+              </a:srgbClr>
+            </a:solidFill>
+            <a:ln w="5420" cap="flat">
+              <a:solidFill>
+                <a:srgbClr val="000000">
+                  <a:alpha val="100000"/>
+                </a:srgbClr>
+              </a:solidFill>
+              <a:prstDash val="solid"/>
+              <a:miter/>
+            </a:ln>
+          </p:spPr>
+          <p:txBody>
+            <a:bodyPr/>
+            <a:lstStyle/>
+            <a:p/>
+          </p:txBody>
+        </p:sp>
+        <p:sp>
+          <p:nvSpPr>
+            <p:cNvPr id="16" name="rc16"/>
+            <p:cNvSpPr/>
+            <p:nvPr/>
+          </p:nvSpPr>
+          <p:spPr>
+            <a:xfrm>
+              <a:off x="4371120" y="3412904"/>
+              <a:ext cx="391006" cy="391006"/>
+            </a:xfrm>
+            <a:prstGeom prst="rect">
+              <a:avLst/>
+            </a:prstGeom>
+            <a:solidFill>
+              <a:srgbClr val="368FA7">
+                <a:alpha val="100000"/>
+              </a:srgbClr>
+            </a:solidFill>
+            <a:ln w="5420" cap="flat">
+              <a:solidFill>
+                <a:srgbClr val="000000">
+                  <a:alpha val="100000"/>
+                </a:srgbClr>
+              </a:solidFill>
+              <a:prstDash val="solid"/>
+              <a:miter/>
+            </a:ln>
+          </p:spPr>
+          <p:txBody>
+            <a:bodyPr/>
+            <a:lstStyle/>
+            <a:p/>
+          </p:txBody>
+        </p:sp>
+        <p:sp>
+          <p:nvSpPr>
+            <p:cNvPr id="17" name="rc17"/>
+            <p:cNvSpPr/>
+            <p:nvPr/>
+          </p:nvSpPr>
+          <p:spPr>
+            <a:xfrm>
+              <a:off x="4371120" y="4976930"/>
+              <a:ext cx="391006" cy="391006"/>
+            </a:xfrm>
+            <a:prstGeom prst="rect">
+              <a:avLst/>
+            </a:prstGeom>
+            <a:solidFill>
+              <a:srgbClr val="39609D">
+                <a:alpha val="100000"/>
+              </a:srgbClr>
+            </a:solidFill>
+            <a:ln w="5420" cap="flat">
+              <a:solidFill>
+                <a:srgbClr val="000000">
+                  <a:alpha val="100000"/>
+                </a:srgbClr>
+              </a:solidFill>
+              <a:prstDash val="solid"/>
+              <a:miter/>
+            </a:ln>
+          </p:spPr>
+          <p:txBody>
+            <a:bodyPr/>
+            <a:lstStyle/>
+            <a:p/>
+          </p:txBody>
+        </p:sp>
+        <p:sp>
+          <p:nvSpPr>
+            <p:cNvPr id="18" name="rc18"/>
+            <p:cNvSpPr/>
+            <p:nvPr/>
+          </p:nvSpPr>
+          <p:spPr>
+            <a:xfrm>
+              <a:off x="4371120" y="3803910"/>
+              <a:ext cx="391006" cy="391006"/>
+            </a:xfrm>
+            <a:prstGeom prst="rect">
+              <a:avLst/>
+            </a:prstGeom>
+            <a:solidFill>
+              <a:srgbClr val="4CB1AB">
+                <a:alpha val="100000"/>
+              </a:srgbClr>
+            </a:solidFill>
+            <a:ln w="5420" cap="flat">
+              <a:solidFill>
+                <a:srgbClr val="000000">
+                  <a:alpha val="100000"/>
+                </a:srgbClr>
+              </a:solidFill>
+              <a:prstDash val="solid"/>
+              <a:miter/>
+            </a:ln>
+          </p:spPr>
+          <p:txBody>
+            <a:bodyPr/>
+            <a:lstStyle/>
+            <a:p/>
+          </p:txBody>
+        </p:sp>
+        <p:sp>
+          <p:nvSpPr>
+            <p:cNvPr id="19" name="rc19"/>
+            <p:cNvSpPr/>
+            <p:nvPr/>
+          </p:nvSpPr>
+          <p:spPr>
+            <a:xfrm>
+              <a:off x="4371120" y="4585923"/>
+              <a:ext cx="391006" cy="391006"/>
+            </a:xfrm>
+            <a:prstGeom prst="rect">
+              <a:avLst/>
+            </a:prstGeom>
+            <a:solidFill>
+              <a:srgbClr val="3A6DA0">
+                <a:alpha val="100000"/>
+              </a:srgbClr>
+            </a:solidFill>
+            <a:ln w="5420" cap="flat">
+              <a:solidFill>
+                <a:srgbClr val="000000">
+                  <a:alpha val="100000"/>
+                </a:srgbClr>
+              </a:solidFill>
+              <a:prstDash val="solid"/>
+              <a:miter/>
+            </a:ln>
+          </p:spPr>
+          <p:txBody>
+            <a:bodyPr/>
+            <a:lstStyle/>
+            <a:p/>
+          </p:txBody>
+        </p:sp>
+        <p:sp>
+          <p:nvSpPr>
+            <p:cNvPr id="20" name="rc20"/>
+            <p:cNvSpPr/>
+            <p:nvPr/>
+          </p:nvSpPr>
+          <p:spPr>
+            <a:xfrm>
+              <a:off x="4371120" y="2239884"/>
+              <a:ext cx="391006" cy="391006"/>
+            </a:xfrm>
+            <a:prstGeom prst="rect">
+              <a:avLst/>
+            </a:prstGeom>
+            <a:solidFill>
+              <a:srgbClr val="3B548F">
+                <a:alpha val="100000"/>
+              </a:srgbClr>
+            </a:solidFill>
+            <a:ln w="5420" cap="flat">
+              <a:solidFill>
+                <a:srgbClr val="000000">
+                  <a:alpha val="100000"/>
+                </a:srgbClr>
+              </a:solidFill>
+              <a:prstDash val="solid"/>
+              <a:miter/>
+            </a:ln>
+          </p:spPr>
+          <p:txBody>
+            <a:bodyPr/>
+            <a:lstStyle/>
+            <a:p/>
+          </p:txBody>
+        </p:sp>
+        <p:sp>
+          <p:nvSpPr>
             <p:cNvPr id="21" name="rc21"/>
             <p:cNvSpPr/>
             <p:nvPr/>
@@ -10017,7 +9161,7 @@
               <a:avLst/>
             </a:prstGeom>
             <a:solidFill>
-              <a:srgbClr val="3B538E">
+              <a:srgbClr val="48ACAA">
                 <a:alpha val="100000"/>
               </a:srgbClr>
             </a:solidFill>
@@ -11165,7 +10309,7 @@
           </p:nvSpPr>
           <p:spPr>
             <a:xfrm>
-              <a:off x="5185559" y="3481852"/>
+              <a:off x="5185559" y="3612045"/>
               <a:ext cx="43891" cy="0"/>
             </a:xfrm>
             <a:custGeom>
@@ -11205,7 +10349,7 @@
           </p:nvSpPr>
           <p:spPr>
             <a:xfrm>
-              <a:off x="5185559" y="3169388"/>
+              <a:off x="5185559" y="3429774"/>
               <a:ext cx="43891" cy="0"/>
             </a:xfrm>
             <a:custGeom>
@@ -11245,7 +10389,7 @@
           </p:nvSpPr>
           <p:spPr>
             <a:xfrm>
-              <a:off x="5185559" y="2856924"/>
+              <a:off x="5185559" y="3247504"/>
               <a:ext cx="43891" cy="0"/>
             </a:xfrm>
             <a:custGeom>
@@ -11285,6 +10429,126 @@
           </p:nvSpPr>
           <p:spPr>
             <a:xfrm>
+              <a:off x="5185559" y="3065234"/>
+              <a:ext cx="43891" cy="0"/>
+            </a:xfrm>
+            <a:custGeom>
+              <a:avLst/>
+              <a:pathLst>
+                <a:path w="43891" h="0">
+                  <a:moveTo>
+                    <a:pt x="0" y="0"/>
+                  </a:moveTo>
+                  <a:lnTo>
+                    <a:pt x="43891" y="0"/>
+                  </a:lnTo>
+                </a:path>
+              </a:pathLst>
+            </a:custGeom>
+            <a:ln w="4762" cap="flat">
+              <a:solidFill>
+                <a:srgbClr val="FFFFFF">
+                  <a:alpha val="100000"/>
+                </a:srgbClr>
+              </a:solidFill>
+              <a:prstDash val="solid"/>
+              <a:round/>
+            </a:ln>
+          </p:spPr>
+          <p:txBody>
+            <a:bodyPr/>
+            <a:lstStyle/>
+            <a:p/>
+          </p:txBody>
+        </p:sp>
+        <p:sp>
+          <p:nvSpPr>
+            <p:cNvPr id="53" name="pl53"/>
+            <p:cNvSpPr/>
+            <p:nvPr/>
+          </p:nvSpPr>
+          <p:spPr>
+            <a:xfrm>
+              <a:off x="5185559" y="2882963"/>
+              <a:ext cx="43891" cy="0"/>
+            </a:xfrm>
+            <a:custGeom>
+              <a:avLst/>
+              <a:pathLst>
+                <a:path w="43891" h="0">
+                  <a:moveTo>
+                    <a:pt x="0" y="0"/>
+                  </a:moveTo>
+                  <a:lnTo>
+                    <a:pt x="43891" y="0"/>
+                  </a:lnTo>
+                </a:path>
+              </a:pathLst>
+            </a:custGeom>
+            <a:ln w="4762" cap="flat">
+              <a:solidFill>
+                <a:srgbClr val="FFFFFF">
+                  <a:alpha val="100000"/>
+                </a:srgbClr>
+              </a:solidFill>
+              <a:prstDash val="solid"/>
+              <a:round/>
+            </a:ln>
+          </p:spPr>
+          <p:txBody>
+            <a:bodyPr/>
+            <a:lstStyle/>
+            <a:p/>
+          </p:txBody>
+        </p:sp>
+        <p:sp>
+          <p:nvSpPr>
+            <p:cNvPr id="54" name="pl54"/>
+            <p:cNvSpPr/>
+            <p:nvPr/>
+          </p:nvSpPr>
+          <p:spPr>
+            <a:xfrm>
+              <a:off x="5185559" y="2700693"/>
+              <a:ext cx="43891" cy="0"/>
+            </a:xfrm>
+            <a:custGeom>
+              <a:avLst/>
+              <a:pathLst>
+                <a:path w="43891" h="0">
+                  <a:moveTo>
+                    <a:pt x="0" y="0"/>
+                  </a:moveTo>
+                  <a:lnTo>
+                    <a:pt x="43891" y="0"/>
+                  </a:lnTo>
+                </a:path>
+              </a:pathLst>
+            </a:custGeom>
+            <a:ln w="4762" cap="flat">
+              <a:solidFill>
+                <a:srgbClr val="FFFFFF">
+                  <a:alpha val="100000"/>
+                </a:srgbClr>
+              </a:solidFill>
+              <a:prstDash val="solid"/>
+              <a:round/>
+            </a:ln>
+          </p:spPr>
+          <p:txBody>
+            <a:bodyPr/>
+            <a:lstStyle/>
+            <a:p/>
+          </p:txBody>
+        </p:sp>
+        <p:sp>
+          <p:nvSpPr>
+            <p:cNvPr id="55" name="pl55"/>
+            <p:cNvSpPr/>
+            <p:nvPr/>
+          </p:nvSpPr>
+          <p:spPr>
+            <a:xfrm>
               <a:off x="5009994" y="3794315"/>
               <a:ext cx="43891" cy="0"/>
             </a:xfrm>
@@ -11319,13 +10583,13 @@
         </p:sp>
         <p:sp>
           <p:nvSpPr>
-            <p:cNvPr id="53" name="pl53"/>
-            <p:cNvSpPr/>
-            <p:nvPr/>
-          </p:nvSpPr>
-          <p:spPr>
-            <a:xfrm>
-              <a:off x="5009994" y="3481852"/>
+            <p:cNvPr id="56" name="pl56"/>
+            <p:cNvSpPr/>
+            <p:nvPr/>
+          </p:nvSpPr>
+          <p:spPr>
+            <a:xfrm>
+              <a:off x="5009994" y="3612045"/>
               <a:ext cx="43891" cy="0"/>
             </a:xfrm>
             <a:custGeom>
@@ -11359,13 +10623,13 @@
         </p:sp>
         <p:sp>
           <p:nvSpPr>
-            <p:cNvPr id="54" name="pl54"/>
-            <p:cNvSpPr/>
-            <p:nvPr/>
-          </p:nvSpPr>
-          <p:spPr>
-            <a:xfrm>
-              <a:off x="5009994" y="3169388"/>
+            <p:cNvPr id="57" name="pl57"/>
+            <p:cNvSpPr/>
+            <p:nvPr/>
+          </p:nvSpPr>
+          <p:spPr>
+            <a:xfrm>
+              <a:off x="5009994" y="3429774"/>
               <a:ext cx="43891" cy="0"/>
             </a:xfrm>
             <a:custGeom>
@@ -11399,13 +10663,13 @@
         </p:sp>
         <p:sp>
           <p:nvSpPr>
-            <p:cNvPr id="55" name="pl55"/>
-            <p:cNvSpPr/>
-            <p:nvPr/>
-          </p:nvSpPr>
-          <p:spPr>
-            <a:xfrm>
-              <a:off x="5009994" y="2856924"/>
+            <p:cNvPr id="58" name="pl58"/>
+            <p:cNvSpPr/>
+            <p:nvPr/>
+          </p:nvSpPr>
+          <p:spPr>
+            <a:xfrm>
+              <a:off x="5009994" y="3247504"/>
               <a:ext cx="43891" cy="0"/>
             </a:xfrm>
             <a:custGeom>
@@ -11439,7 +10703,127 @@
         </p:sp>
         <p:sp>
           <p:nvSpPr>
-            <p:cNvPr id="56" name="tx56"/>
+            <p:cNvPr id="59" name="pl59"/>
+            <p:cNvSpPr/>
+            <p:nvPr/>
+          </p:nvSpPr>
+          <p:spPr>
+            <a:xfrm>
+              <a:off x="5009994" y="3065234"/>
+              <a:ext cx="43891" cy="0"/>
+            </a:xfrm>
+            <a:custGeom>
+              <a:avLst/>
+              <a:pathLst>
+                <a:path w="43891" h="0">
+                  <a:moveTo>
+                    <a:pt x="43891" y="0"/>
+                  </a:moveTo>
+                  <a:lnTo>
+                    <a:pt x="0" y="0"/>
+                  </a:lnTo>
+                </a:path>
+              </a:pathLst>
+            </a:custGeom>
+            <a:ln w="4762" cap="flat">
+              <a:solidFill>
+                <a:srgbClr val="FFFFFF">
+                  <a:alpha val="100000"/>
+                </a:srgbClr>
+              </a:solidFill>
+              <a:prstDash val="solid"/>
+              <a:round/>
+            </a:ln>
+          </p:spPr>
+          <p:txBody>
+            <a:bodyPr/>
+            <a:lstStyle/>
+            <a:p/>
+          </p:txBody>
+        </p:sp>
+        <p:sp>
+          <p:nvSpPr>
+            <p:cNvPr id="60" name="pl60"/>
+            <p:cNvSpPr/>
+            <p:nvPr/>
+          </p:nvSpPr>
+          <p:spPr>
+            <a:xfrm>
+              <a:off x="5009994" y="2882963"/>
+              <a:ext cx="43891" cy="0"/>
+            </a:xfrm>
+            <a:custGeom>
+              <a:avLst/>
+              <a:pathLst>
+                <a:path w="43891" h="0">
+                  <a:moveTo>
+                    <a:pt x="43891" y="0"/>
+                  </a:moveTo>
+                  <a:lnTo>
+                    <a:pt x="0" y="0"/>
+                  </a:lnTo>
+                </a:path>
+              </a:pathLst>
+            </a:custGeom>
+            <a:ln w="4762" cap="flat">
+              <a:solidFill>
+                <a:srgbClr val="FFFFFF">
+                  <a:alpha val="100000"/>
+                </a:srgbClr>
+              </a:solidFill>
+              <a:prstDash val="solid"/>
+              <a:round/>
+            </a:ln>
+          </p:spPr>
+          <p:txBody>
+            <a:bodyPr/>
+            <a:lstStyle/>
+            <a:p/>
+          </p:txBody>
+        </p:sp>
+        <p:sp>
+          <p:nvSpPr>
+            <p:cNvPr id="61" name="pl61"/>
+            <p:cNvSpPr/>
+            <p:nvPr/>
+          </p:nvSpPr>
+          <p:spPr>
+            <a:xfrm>
+              <a:off x="5009994" y="2700693"/>
+              <a:ext cx="43891" cy="0"/>
+            </a:xfrm>
+            <a:custGeom>
+              <a:avLst/>
+              <a:pathLst>
+                <a:path w="43891" h="0">
+                  <a:moveTo>
+                    <a:pt x="43891" y="0"/>
+                  </a:moveTo>
+                  <a:lnTo>
+                    <a:pt x="0" y="0"/>
+                  </a:lnTo>
+                </a:path>
+              </a:pathLst>
+            </a:custGeom>
+            <a:ln w="4762" cap="flat">
+              <a:solidFill>
+                <a:srgbClr val="FFFFFF">
+                  <a:alpha val="100000"/>
+                </a:srgbClr>
+              </a:solidFill>
+              <a:prstDash val="solid"/>
+              <a:round/>
+            </a:ln>
+          </p:spPr>
+          <p:txBody>
+            <a:bodyPr/>
+            <a:lstStyle/>
+            <a:p/>
+          </p:txBody>
+        </p:sp>
+        <p:sp>
+          <p:nvSpPr>
+            <p:cNvPr id="62" name="tx62"/>
             <p:cNvSpPr/>
             <p:nvPr/>
           </p:nvSpPr>
@@ -11485,13 +10869,59 @@
         </p:sp>
         <p:sp>
           <p:nvSpPr>
-            <p:cNvPr id="57" name="tx57"/>
-            <p:cNvSpPr/>
-            <p:nvPr/>
-          </p:nvSpPr>
-          <p:spPr>
-            <a:xfrm>
-              <a:off x="5299039" y="3441801"/>
+            <p:cNvPr id="63" name="tx63"/>
+            <p:cNvSpPr/>
+            <p:nvPr/>
+          </p:nvSpPr>
+          <p:spPr>
+            <a:xfrm>
+              <a:off x="5299039" y="3571994"/>
+              <a:ext cx="62179" cy="80101"/>
+            </a:xfrm>
+            <a:prstGeom prst="rect">
+              <a:avLst/>
+            </a:prstGeom>
+            <a:noFill/>
+          </p:spPr>
+          <p:txBody>
+            <a:bodyPr lIns="0" rIns="0" tIns="0" bIns="0" anchorCtr="1" anchor="ctr" wrap="none"/>
+            <a:lstStyle/>
+            <a:p>
+              <a:pPr algn="l" marL="0" marR="0" indent="0">
+                <a:lnSpc>
+                  <a:spcPts val="880"/>
+                </a:lnSpc>
+                <a:spcBef>
+                  <a:spcPts val="0"/>
+                </a:spcBef>
+                <a:spcAft>
+                  <a:spcPts val="0"/>
+                </a:spcAft>
+              </a:pPr>
+              <a:r>
+                <a:rPr sz="880">
+                  <a:solidFill>
+                    <a:srgbClr val="000000">
+                      <a:alpha val="100000"/>
+                    </a:srgbClr>
+                  </a:solidFill>
+                  <a:latin typeface="Helvetica"/>
+                  <a:cs typeface="Helvetica"/>
+                </a:rPr>
+                <a:t>1</a:t>
+              </a:r>
+            </a:p>
+          </p:txBody>
+        </p:sp>
+        <p:sp>
+          <p:nvSpPr>
+            <p:cNvPr id="64" name="tx64"/>
+            <p:cNvSpPr/>
+            <p:nvPr/>
+          </p:nvSpPr>
+          <p:spPr>
+            <a:xfrm>
+              <a:off x="5299039" y="3389724"/>
               <a:ext cx="62179" cy="80101"/>
             </a:xfrm>
             <a:prstGeom prst="rect">
@@ -11531,13 +10961,59 @@
         </p:sp>
         <p:sp>
           <p:nvSpPr>
-            <p:cNvPr id="58" name="tx58"/>
-            <p:cNvSpPr/>
-            <p:nvPr/>
-          </p:nvSpPr>
-          <p:spPr>
-            <a:xfrm>
-              <a:off x="5299039" y="3129337"/>
+            <p:cNvPr id="65" name="tx65"/>
+            <p:cNvSpPr/>
+            <p:nvPr/>
+          </p:nvSpPr>
+          <p:spPr>
+            <a:xfrm>
+              <a:off x="5299039" y="3207453"/>
+              <a:ext cx="62179" cy="80101"/>
+            </a:xfrm>
+            <a:prstGeom prst="rect">
+              <a:avLst/>
+            </a:prstGeom>
+            <a:noFill/>
+          </p:spPr>
+          <p:txBody>
+            <a:bodyPr lIns="0" rIns="0" tIns="0" bIns="0" anchorCtr="1" anchor="ctr" wrap="none"/>
+            <a:lstStyle/>
+            <a:p>
+              <a:pPr algn="l" marL="0" marR="0" indent="0">
+                <a:lnSpc>
+                  <a:spcPts val="880"/>
+                </a:lnSpc>
+                <a:spcBef>
+                  <a:spcPts val="0"/>
+                </a:spcBef>
+                <a:spcAft>
+                  <a:spcPts val="0"/>
+                </a:spcAft>
+              </a:pPr>
+              <a:r>
+                <a:rPr sz="880">
+                  <a:solidFill>
+                    <a:srgbClr val="000000">
+                      <a:alpha val="100000"/>
+                    </a:srgbClr>
+                  </a:solidFill>
+                  <a:latin typeface="Helvetica"/>
+                  <a:cs typeface="Helvetica"/>
+                </a:rPr>
+                <a:t>3</a:t>
+              </a:r>
+            </a:p>
+          </p:txBody>
+        </p:sp>
+        <p:sp>
+          <p:nvSpPr>
+            <p:cNvPr id="66" name="tx66"/>
+            <p:cNvSpPr/>
+            <p:nvPr/>
+          </p:nvSpPr>
+          <p:spPr>
+            <a:xfrm>
+              <a:off x="5299039" y="3025183"/>
               <a:ext cx="62179" cy="80101"/>
             </a:xfrm>
             <a:prstGeom prst="rect">
@@ -11577,13 +11053,59 @@
         </p:sp>
         <p:sp>
           <p:nvSpPr>
-            <p:cNvPr id="59" name="tx59"/>
-            <p:cNvSpPr/>
-            <p:nvPr/>
-          </p:nvSpPr>
-          <p:spPr>
-            <a:xfrm>
-              <a:off x="5299039" y="2816874"/>
+            <p:cNvPr id="67" name="tx67"/>
+            <p:cNvSpPr/>
+            <p:nvPr/>
+          </p:nvSpPr>
+          <p:spPr>
+            <a:xfrm>
+              <a:off x="5299039" y="2842912"/>
+              <a:ext cx="62179" cy="80101"/>
+            </a:xfrm>
+            <a:prstGeom prst="rect">
+              <a:avLst/>
+            </a:prstGeom>
+            <a:noFill/>
+          </p:spPr>
+          <p:txBody>
+            <a:bodyPr lIns="0" rIns="0" tIns="0" bIns="0" anchorCtr="1" anchor="ctr" wrap="none"/>
+            <a:lstStyle/>
+            <a:p>
+              <a:pPr algn="l" marL="0" marR="0" indent="0">
+                <a:lnSpc>
+                  <a:spcPts val="880"/>
+                </a:lnSpc>
+                <a:spcBef>
+                  <a:spcPts val="0"/>
+                </a:spcBef>
+                <a:spcAft>
+                  <a:spcPts val="0"/>
+                </a:spcAft>
+              </a:pPr>
+              <a:r>
+                <a:rPr sz="880">
+                  <a:solidFill>
+                    <a:srgbClr val="000000">
+                      <a:alpha val="100000"/>
+                    </a:srgbClr>
+                  </a:solidFill>
+                  <a:latin typeface="Helvetica"/>
+                  <a:cs typeface="Helvetica"/>
+                </a:rPr>
+                <a:t>5</a:t>
+              </a:r>
+            </a:p>
+          </p:txBody>
+        </p:sp>
+        <p:sp>
+          <p:nvSpPr>
+            <p:cNvPr id="68" name="tx68"/>
+            <p:cNvSpPr/>
+            <p:nvPr/>
+          </p:nvSpPr>
+          <p:spPr>
+            <a:xfrm>
+              <a:off x="5299039" y="2660642"/>
               <a:ext cx="62179" cy="80101"/>
             </a:xfrm>
             <a:prstGeom prst="rect">
@@ -11623,7 +11145,7 @@
         </p:sp>
         <p:sp>
           <p:nvSpPr>
-            <p:cNvPr id="60" name="tx60"/>
+            <p:cNvPr id="69" name="tx69"/>
             <p:cNvSpPr/>
             <p:nvPr/>
           </p:nvSpPr>
@@ -11669,7 +11191,7 @@
         </p:sp>
         <p:sp>
           <p:nvSpPr>
-            <p:cNvPr id="61" name="tx61"/>
+            <p:cNvPr id="70" name="tx70"/>
             <p:cNvSpPr/>
             <p:nvPr/>
           </p:nvSpPr>

</xml_diff>